<commit_message>
Deck re-baselined to long+lend; equity chart adds price-only line; MC density-normalized
- build_deck.js added to repo; deck slides 5/7/8/9/10/11 re-baselined:
  $28.9M/29%/1.65/-16%, benchmark table, per-scenario leg-split with sample
  sizes (320=217+103, short gate 60%=62), long+lend MC + P(loss)=0%, hedge row
- equity chart: restore the price-only (no-lending) line showing +18% uplift;
  capped pre-COVID; scripts 46/47 added for reproducibility
- MC chart: density-normalized so bootstrap (N=10k) and MC (N=500) compare;
  N labelled in legend
- IC brief: re-embed updated equity + MC charts
</commit_message>
<xml_diff>
--- a/reports/IC_Biotech_Catalyst_Strategy.pptx
+++ b/reports/IC_Biotech_Catalyst_Strategy.pptx
@@ -1216,7 +1216,7 @@
           <a:p>
             <a:r>
               <a:rPr lang="en-US" dirty="0"/>
-              <a:t>Lead with $27.3M / 26% / 1.67 / -15%. The $41M ceiling is context only. Note it is positive across bear/bull and across every year — the beta hedge is why 2016, the crash year, is actually the best Sharpe.</a:t>
+              <a:t>Lead with $28.9M perfect-foresight, but be upfront it's a ceiling; the fair line is the 90% model at $26.1M / +161%, which still beats the S&amp;P's +67% with a smaller drawdown. Benchmarks capped pre-COVID so the 2020 crash doesn't flatter us.</a:t>
             </a:r>
             <a:endParaRPr lang="en-US" dirty="0"/>
           </a:p>
@@ -1304,7 +1304,7 @@
           <a:p>
             <a:r>
               <a:rPr lang="en-US" dirty="0"/>
-              <a:t>Two takeaways: (1) profit is long+lend, ~92% of gross; the short leg nets roughly flat after honest borrow limits. (2) Lending alone adds +19% over price-only — it is the differentiator, not decoration.</a:t>
+              <a:t>Held at 100% model so the columns isolate the cost assumptions. Short is a drag everywhere except bull, and doesn't help neutrality (the XBI hedge does that) — so it's dropped. Long price is steady; lending is what swings the result.</a:t>
             </a:r>
             <a:endParaRPr lang="en-US" dirty="0"/>
           </a:p>
@@ -1392,7 +1392,7 @@
           <a:p>
             <a:r>
               <a:rPr lang="en-US" dirty="0"/>
-              <a:t>This directly answers the committee's earlier question: with accuracy pinned at a common baseline, which-deals-you-get and which-costs-you-assume land in the same place. The downside is driven almost entirely by model accuracy — which is Step 3/4.</a:t>
+              <a:t>Accuracy pinned at a common baseline so trade-luck and assumption-luck are comparable — they land in the same place. Dropping the short leg removed the loss scenarios (P(loss)=0%). Un-hedged is higher; the hedge is a mandate choice. Borrow rate (cost of lending) is the single biggest input — the one-at-a-time MC in the brief shows that.</a:t>
             </a:r>
             <a:endParaRPr lang="en-US" dirty="0"/>
           </a:p>
@@ -3518,212 +3518,6 @@
                           <a:ea typeface="Calibri" pitchFamily="34" charset="-122"/>
                           <a:cs typeface="Calibri" pitchFamily="34" charset="-120"/>
                         </a:rPr>
-                        <a:t>Executability (“keep 60%”)</a:t>
-                      </a:r>
-                      <a:endParaRPr lang="en-US" sz="1300" dirty="0">
-                        <a:latin typeface="Calibri" charset="0"/>
-                        <a:ea typeface="Calibri" charset="0"/>
-                        <a:cs typeface="Calibri" charset="0"/>
-                      </a:endParaRPr>
-                    </a:p>
-                  </a:txBody>
-                  <a:tcPr marL="91440" marR="91440" marT="45720" marB="45720" anchor="ctr">
-                    <a:lnL w="12700" cap="flat" cmpd="sng" algn="ctr">
-                      <a:solidFill>
-                        <a:srgbClr val="E4E6EE"/>
-                      </a:solidFill>
-                      <a:prstDash val="solid"/>
-                      <a:round/>
-                      <a:headEnd type="none" w="med" len="med"/>
-                      <a:tailEnd type="none" w="med" len="med"/>
-                    </a:lnL>
-                    <a:lnR w="12700" cap="flat" cmpd="sng" algn="ctr">
-                      <a:solidFill>
-                        <a:srgbClr val="E4E6EE"/>
-                      </a:solidFill>
-                      <a:prstDash val="solid"/>
-                      <a:round/>
-                      <a:headEnd type="none" w="med" len="med"/>
-                      <a:tailEnd type="none" w="med" len="med"/>
-                    </a:lnR>
-                    <a:lnT w="12700" cap="flat" cmpd="sng" algn="ctr">
-                      <a:solidFill>
-                        <a:srgbClr val="E4E6EE"/>
-                      </a:solidFill>
-                      <a:prstDash val="solid"/>
-                      <a:round/>
-                      <a:headEnd type="none" w="med" len="med"/>
-                      <a:tailEnd type="none" w="med" len="med"/>
-                    </a:lnT>
-                    <a:lnB w="12700" cap="flat" cmpd="sng" algn="ctr">
-                      <a:solidFill>
-                        <a:srgbClr val="E4E6EE"/>
-                      </a:solidFill>
-                      <a:prstDash val="solid"/>
-                      <a:round/>
-                      <a:headEnd type="none" w="med" len="med"/>
-                      <a:tailEnd type="none" w="med" len="med"/>
-                    </a:lnB>
-                    <a:solidFill>
-                      <a:srgbClr val="FFFFFF"/>
-                    </a:solidFill>
-                  </a:tcPr>
-                </a:tc>
-                <a:tc>
-                  <a:txBody>
-                    <a:bodyPr/>
-                    <a:lstStyle/>
-                    <a:p>
-                      <a:pPr algn="ctr" indent="0" marL="0">
-                        <a:buNone/>
-                      </a:pPr>
-                      <a:r>
-                        <a:rPr lang="en-US" sz="1300" dirty="0">
-                          <a:solidFill>
-                            <a:srgbClr val="27313F"/>
-                          </a:solidFill>
-                          <a:latin typeface="Calibri" pitchFamily="34" charset="0"/>
-                          <a:ea typeface="Calibri" pitchFamily="34" charset="-122"/>
-                          <a:cs typeface="Calibri" pitchFamily="34" charset="-120"/>
-                        </a:rPr>
-                        <a:t>60%</a:t>
-                      </a:r>
-                      <a:endParaRPr lang="en-US" sz="1300" dirty="0">
-                        <a:latin typeface="Calibri" charset="0"/>
-                        <a:ea typeface="Calibri" charset="0"/>
-                        <a:cs typeface="Calibri" charset="0"/>
-                      </a:endParaRPr>
-                    </a:p>
-                  </a:txBody>
-                  <a:tcPr marL="91440" marR="91440" marT="45720" marB="45720" anchor="ctr">
-                    <a:lnL w="12700" cap="flat" cmpd="sng" algn="ctr">
-                      <a:solidFill>
-                        <a:srgbClr val="E4E6EE"/>
-                      </a:solidFill>
-                      <a:prstDash val="solid"/>
-                      <a:round/>
-                      <a:headEnd type="none" w="med" len="med"/>
-                      <a:tailEnd type="none" w="med" len="med"/>
-                    </a:lnL>
-                    <a:lnR w="12700" cap="flat" cmpd="sng" algn="ctr">
-                      <a:solidFill>
-                        <a:srgbClr val="E4E6EE"/>
-                      </a:solidFill>
-                      <a:prstDash val="solid"/>
-                      <a:round/>
-                      <a:headEnd type="none" w="med" len="med"/>
-                      <a:tailEnd type="none" w="med" len="med"/>
-                    </a:lnR>
-                    <a:lnT w="12700" cap="flat" cmpd="sng" algn="ctr">
-                      <a:solidFill>
-                        <a:srgbClr val="E4E6EE"/>
-                      </a:solidFill>
-                      <a:prstDash val="solid"/>
-                      <a:round/>
-                      <a:headEnd type="none" w="med" len="med"/>
-                      <a:tailEnd type="none" w="med" len="med"/>
-                    </a:lnT>
-                    <a:lnB w="12700" cap="flat" cmpd="sng" algn="ctr">
-                      <a:solidFill>
-                        <a:srgbClr val="E4E6EE"/>
-                      </a:solidFill>
-                      <a:prstDash val="solid"/>
-                      <a:round/>
-                      <a:headEnd type="none" w="med" len="med"/>
-                      <a:tailEnd type="none" w="med" len="med"/>
-                    </a:lnB>
-                    <a:solidFill>
-                      <a:srgbClr val="FFFFFF"/>
-                    </a:solidFill>
-                  </a:tcPr>
-                </a:tc>
-                <a:tc>
-                  <a:txBody>
-                    <a:bodyPr/>
-                    <a:lstStyle/>
-                    <a:p>
-                      <a:pPr algn="ctr" indent="0" marL="0">
-                        <a:buNone/>
-                      </a:pPr>
-                      <a:r>
-                        <a:rPr lang="en-US" sz="1250" b="1" dirty="0">
-                          <a:solidFill>
-                            <a:srgbClr val="C0392F"/>
-                          </a:solidFill>
-                          <a:latin typeface="Calibri" pitchFamily="34" charset="0"/>
-                          <a:ea typeface="Calibri" pitchFamily="34" charset="-122"/>
-                          <a:cs typeface="Calibri" pitchFamily="34" charset="-120"/>
-                        </a:rPr>
-                        <a:t>assumed</a:t>
-                      </a:r>
-                      <a:endParaRPr lang="en-US" sz="1250" dirty="0">
-                        <a:latin typeface="Calibri" charset="0"/>
-                        <a:ea typeface="Calibri" charset="0"/>
-                        <a:cs typeface="Calibri" charset="0"/>
-                      </a:endParaRPr>
-                    </a:p>
-                  </a:txBody>
-                  <a:tcPr marL="91440" marR="91440" marT="45720" marB="45720" anchor="ctr">
-                    <a:lnL w="12700" cap="flat" cmpd="sng" algn="ctr">
-                      <a:solidFill>
-                        <a:srgbClr val="E4E6EE"/>
-                      </a:solidFill>
-                      <a:prstDash val="solid"/>
-                      <a:round/>
-                      <a:headEnd type="none" w="med" len="med"/>
-                      <a:tailEnd type="none" w="med" len="med"/>
-                    </a:lnL>
-                    <a:lnR w="12700" cap="flat" cmpd="sng" algn="ctr">
-                      <a:solidFill>
-                        <a:srgbClr val="E4E6EE"/>
-                      </a:solidFill>
-                      <a:prstDash val="solid"/>
-                      <a:round/>
-                      <a:headEnd type="none" w="med" len="med"/>
-                      <a:tailEnd type="none" w="med" len="med"/>
-                    </a:lnR>
-                    <a:lnT w="12700" cap="flat" cmpd="sng" algn="ctr">
-                      <a:solidFill>
-                        <a:srgbClr val="E4E6EE"/>
-                      </a:solidFill>
-                      <a:prstDash val="solid"/>
-                      <a:round/>
-                      <a:headEnd type="none" w="med" len="med"/>
-                      <a:tailEnd type="none" w="med" len="med"/>
-                    </a:lnT>
-                    <a:lnB w="12700" cap="flat" cmpd="sng" algn="ctr">
-                      <a:solidFill>
-                        <a:srgbClr val="E4E6EE"/>
-                      </a:solidFill>
-                      <a:prstDash val="solid"/>
-                      <a:round/>
-                      <a:headEnd type="none" w="med" len="med"/>
-                      <a:tailEnd type="none" w="med" len="med"/>
-                    </a:lnB>
-                    <a:solidFill>
-                      <a:srgbClr val="FFFFFF"/>
-                    </a:solidFill>
-                  </a:tcPr>
-                </a:tc>
-              </a:tr>
-              <a:tr h="502920">
-                <a:tc>
-                  <a:txBody>
-                    <a:bodyPr/>
-                    <a:lstStyle/>
-                    <a:p>
-                      <a:pPr algn="l" indent="0" marL="0">
-                        <a:buNone/>
-                      </a:pPr>
-                      <a:r>
-                        <a:rPr lang="en-US" sz="1300" dirty="0">
-                          <a:solidFill>
-                            <a:srgbClr val="27313F"/>
-                          </a:solidFill>
-                          <a:latin typeface="Calibri" pitchFamily="34" charset="0"/>
-                          <a:ea typeface="Calibri" pitchFamily="34" charset="-122"/>
-                          <a:cs typeface="Calibri" pitchFamily="34" charset="-120"/>
-                        </a:rPr>
                         <a:t>Model accuracy</a:t>
                       </a:r>
                       <a:endParaRPr lang="en-US" sz="1300" dirty="0">
@@ -3860,7 +3654,213 @@
                           <a:ea typeface="Calibri" pitchFamily="34" charset="-122"/>
                           <a:cs typeface="Calibri" pitchFamily="34" charset="-120"/>
                         </a:rPr>
-                        <a:t>ceiling only</a:t>
+                        <a:t>ceiling only — 90/80% in MC</a:t>
+                      </a:r>
+                      <a:endParaRPr lang="en-US" sz="1250" dirty="0">
+                        <a:latin typeface="Calibri" charset="0"/>
+                        <a:ea typeface="Calibri" charset="0"/>
+                        <a:cs typeface="Calibri" charset="0"/>
+                      </a:endParaRPr>
+                    </a:p>
+                  </a:txBody>
+                  <a:tcPr marL="91440" marR="91440" marT="45720" marB="45720" anchor="ctr">
+                    <a:lnL w="12700" cap="flat" cmpd="sng" algn="ctr">
+                      <a:solidFill>
+                        <a:srgbClr val="E4E6EE"/>
+                      </a:solidFill>
+                      <a:prstDash val="solid"/>
+                      <a:round/>
+                      <a:headEnd type="none" w="med" len="med"/>
+                      <a:tailEnd type="none" w="med" len="med"/>
+                    </a:lnL>
+                    <a:lnR w="12700" cap="flat" cmpd="sng" algn="ctr">
+                      <a:solidFill>
+                        <a:srgbClr val="E4E6EE"/>
+                      </a:solidFill>
+                      <a:prstDash val="solid"/>
+                      <a:round/>
+                      <a:headEnd type="none" w="med" len="med"/>
+                      <a:tailEnd type="none" w="med" len="med"/>
+                    </a:lnR>
+                    <a:lnT w="12700" cap="flat" cmpd="sng" algn="ctr">
+                      <a:solidFill>
+                        <a:srgbClr val="E4E6EE"/>
+                      </a:solidFill>
+                      <a:prstDash val="solid"/>
+                      <a:round/>
+                      <a:headEnd type="none" w="med" len="med"/>
+                      <a:tailEnd type="none" w="med" len="med"/>
+                    </a:lnT>
+                    <a:lnB w="12700" cap="flat" cmpd="sng" algn="ctr">
+                      <a:solidFill>
+                        <a:srgbClr val="E4E6EE"/>
+                      </a:solidFill>
+                      <a:prstDash val="solid"/>
+                      <a:round/>
+                      <a:headEnd type="none" w="med" len="med"/>
+                      <a:tailEnd type="none" w="med" len="med"/>
+                    </a:lnB>
+                    <a:solidFill>
+                      <a:srgbClr val="FFFFFF"/>
+                    </a:solidFill>
+                  </a:tcPr>
+                </a:tc>
+              </a:tr>
+              <a:tr h="502920">
+                <a:tc>
+                  <a:txBody>
+                    <a:bodyPr/>
+                    <a:lstStyle/>
+                    <a:p>
+                      <a:pPr algn="l" indent="0" marL="0">
+                        <a:buNone/>
+                      </a:pPr>
+                      <a:r>
+                        <a:rPr lang="en-US" sz="1300" dirty="0">
+                          <a:solidFill>
+                            <a:srgbClr val="27313F"/>
+                          </a:solidFill>
+                          <a:latin typeface="Calibri" pitchFamily="34" charset="0"/>
+                          <a:ea typeface="Calibri" pitchFamily="34" charset="-122"/>
+                          <a:cs typeface="Calibri" pitchFamily="34" charset="-120"/>
+                        </a:rPr>
+                        <a:t>XBI hedge</a:t>
+                      </a:r>
+                      <a:endParaRPr lang="en-US" sz="1300" dirty="0">
+                        <a:latin typeface="Calibri" charset="0"/>
+                        <a:ea typeface="Calibri" charset="0"/>
+                        <a:cs typeface="Calibri" charset="0"/>
+                      </a:endParaRPr>
+                    </a:p>
+                  </a:txBody>
+                  <a:tcPr marL="91440" marR="91440" marT="45720" marB="45720" anchor="ctr">
+                    <a:lnL w="12700" cap="flat" cmpd="sng" algn="ctr">
+                      <a:solidFill>
+                        <a:srgbClr val="E4E6EE"/>
+                      </a:solidFill>
+                      <a:prstDash val="solid"/>
+                      <a:round/>
+                      <a:headEnd type="none" w="med" len="med"/>
+                      <a:tailEnd type="none" w="med" len="med"/>
+                    </a:lnL>
+                    <a:lnR w="12700" cap="flat" cmpd="sng" algn="ctr">
+                      <a:solidFill>
+                        <a:srgbClr val="E4E6EE"/>
+                      </a:solidFill>
+                      <a:prstDash val="solid"/>
+                      <a:round/>
+                      <a:headEnd type="none" w="med" len="med"/>
+                      <a:tailEnd type="none" w="med" len="med"/>
+                    </a:lnR>
+                    <a:lnT w="12700" cap="flat" cmpd="sng" algn="ctr">
+                      <a:solidFill>
+                        <a:srgbClr val="E4E6EE"/>
+                      </a:solidFill>
+                      <a:prstDash val="solid"/>
+                      <a:round/>
+                      <a:headEnd type="none" w="med" len="med"/>
+                      <a:tailEnd type="none" w="med" len="med"/>
+                    </a:lnT>
+                    <a:lnB w="12700" cap="flat" cmpd="sng" algn="ctr">
+                      <a:solidFill>
+                        <a:srgbClr val="E4E6EE"/>
+                      </a:solidFill>
+                      <a:prstDash val="solid"/>
+                      <a:round/>
+                      <a:headEnd type="none" w="med" len="med"/>
+                      <a:tailEnd type="none" w="med" len="med"/>
+                    </a:lnB>
+                    <a:solidFill>
+                      <a:srgbClr val="FFFFFF"/>
+                    </a:solidFill>
+                  </a:tcPr>
+                </a:tc>
+                <a:tc>
+                  <a:txBody>
+                    <a:bodyPr/>
+                    <a:lstStyle/>
+                    <a:p>
+                      <a:pPr algn="ctr" indent="0" marL="0">
+                        <a:buNone/>
+                      </a:pPr>
+                      <a:r>
+                        <a:rPr lang="en-US" sz="1300" dirty="0">
+                          <a:solidFill>
+                            <a:srgbClr val="27313F"/>
+                          </a:solidFill>
+                          <a:latin typeface="Calibri" pitchFamily="34" charset="0"/>
+                          <a:ea typeface="Calibri" pitchFamily="34" charset="-122"/>
+                          <a:cs typeface="Calibri" pitchFamily="34" charset="-120"/>
+                        </a:rPr>
+                        <a:t>on</a:t>
+                      </a:r>
+                      <a:endParaRPr lang="en-US" sz="1300" dirty="0">
+                        <a:latin typeface="Calibri" charset="0"/>
+                        <a:ea typeface="Calibri" charset="0"/>
+                        <a:cs typeface="Calibri" charset="0"/>
+                      </a:endParaRPr>
+                    </a:p>
+                  </a:txBody>
+                  <a:tcPr marL="91440" marR="91440" marT="45720" marB="45720" anchor="ctr">
+                    <a:lnL w="12700" cap="flat" cmpd="sng" algn="ctr">
+                      <a:solidFill>
+                        <a:srgbClr val="E4E6EE"/>
+                      </a:solidFill>
+                      <a:prstDash val="solid"/>
+                      <a:round/>
+                      <a:headEnd type="none" w="med" len="med"/>
+                      <a:tailEnd type="none" w="med" len="med"/>
+                    </a:lnL>
+                    <a:lnR w="12700" cap="flat" cmpd="sng" algn="ctr">
+                      <a:solidFill>
+                        <a:srgbClr val="E4E6EE"/>
+                      </a:solidFill>
+                      <a:prstDash val="solid"/>
+                      <a:round/>
+                      <a:headEnd type="none" w="med" len="med"/>
+                      <a:tailEnd type="none" w="med" len="med"/>
+                    </a:lnR>
+                    <a:lnT w="12700" cap="flat" cmpd="sng" algn="ctr">
+                      <a:solidFill>
+                        <a:srgbClr val="E4E6EE"/>
+                      </a:solidFill>
+                      <a:prstDash val="solid"/>
+                      <a:round/>
+                      <a:headEnd type="none" w="med" len="med"/>
+                      <a:tailEnd type="none" w="med" len="med"/>
+                    </a:lnT>
+                    <a:lnB w="12700" cap="flat" cmpd="sng" algn="ctr">
+                      <a:solidFill>
+                        <a:srgbClr val="E4E6EE"/>
+                      </a:solidFill>
+                      <a:prstDash val="solid"/>
+                      <a:round/>
+                      <a:headEnd type="none" w="med" len="med"/>
+                      <a:tailEnd type="none" w="med" len="med"/>
+                    </a:lnB>
+                    <a:solidFill>
+                      <a:srgbClr val="FFFFFF"/>
+                    </a:solidFill>
+                  </a:tcPr>
+                </a:tc>
+                <a:tc>
+                  <a:txBody>
+                    <a:bodyPr/>
+                    <a:lstStyle/>
+                    <a:p>
+                      <a:pPr algn="ctr" indent="0" marL="0">
+                        <a:buNone/>
+                      </a:pPr>
+                      <a:r>
+                        <a:rPr lang="en-US" sz="1250" b="1" dirty="0">
+                          <a:solidFill>
+                            <a:srgbClr val="E0A458"/>
+                          </a:solidFill>
+                          <a:latin typeface="Calibri" pitchFamily="34" charset="0"/>
+                          <a:ea typeface="Calibri" pitchFamily="34" charset="-122"/>
+                          <a:cs typeface="Calibri" pitchFamily="34" charset="-120"/>
+                        </a:rPr>
+                        <a:t>optional — cost return here</a:t>
                       </a:r>
                       <a:endParaRPr lang="en-US" sz="1250" dirty="0">
                         <a:latin typeface="Calibri" charset="0"/>
@@ -3924,12 +3924,12 @@
         </p:nvSpPr>
         <p:spPr>
           <a:xfrm>
-            <a:off x="548640" y="5349240"/>
-            <a:ext cx="11064240" cy="777240"/>
+            <a:off x="548640" y="5212080"/>
+            <a:ext cx="11064240" cy="914400"/>
           </a:xfrm>
           <a:prstGeom prst="roundRect">
             <a:avLst>
-              <a:gd name="adj" fmla="val 9412"/>
+              <a:gd name="adj" fmla="val 8000"/>
             </a:avLst>
           </a:prstGeom>
           <a:solidFill>
@@ -3951,8 +3951,8 @@
         </p:nvSpPr>
         <p:spPr>
           <a:xfrm>
-            <a:off x="777240" y="5440680"/>
-            <a:ext cx="10607040" cy="594360"/>
+            <a:off x="777240" y="5303520"/>
+            <a:ext cx="10607040" cy="749808"/>
           </a:xfrm>
           <a:prstGeom prst="rect">
             <a:avLst/>
@@ -3965,10 +3965,13 @@
           <a:lstStyle/>
           <a:p>
             <a:pPr indent="0" marL="0">
-              <a:buNone/>
-            </a:pPr>
-            <a:r>
-              <a:rPr lang="en-US" sz="1300" b="1" dirty="0">
+              <a:lnSpc>
+                <a:spcPct val="112000"/>
+              </a:lnSpc>
+              <a:buNone/>
+            </a:pPr>
+            <a:r>
+              <a:rPr lang="en-US" sz="1250" b="1" dirty="0">
                 <a:solidFill>
                   <a:srgbClr val="C0392F"/>
                 </a:solidFill>
@@ -3976,13 +3979,16 @@
                 <a:ea typeface="Calibri" pitchFamily="34" charset="-122"/>
                 <a:cs typeface="Calibri" pitchFamily="34" charset="-120"/>
               </a:rPr>
-              <a:t>The two red rows — borrow economics and short executability — are the real uncertainty.  </a:t>
+              <a:t>The real uncertainty is borrow economics and model accuracy.  </a:t>
             </a:r>
             <a:pPr indent="0" marL="0">
-              <a:buNone/>
-            </a:pPr>
-            <a:r>
-              <a:rPr lang="en-US" sz="1300" dirty="0">
+              <a:lnSpc>
+                <a:spcPct val="112000"/>
+              </a:lnSpc>
+              <a:buNone/>
+            </a:pPr>
+            <a:r>
+              <a:rPr lang="en-US" sz="1250" dirty="0">
                 <a:solidFill>
                   <a:srgbClr val="27313F"/>
                 </a:solidFill>
@@ -3990,9 +3996,9 @@
                 <a:ea typeface="Calibri" pitchFamily="34" charset="-122"/>
                 <a:cs typeface="Calibri" pitchFamily="34" charset="-120"/>
               </a:rPr>
-              <a:t>Both are swept in the sensitivity and Monte Carlo; neither breaks the strategy, but both are un-measured until we trade it.</a:t>
-            </a:r>
-            <a:endParaRPr lang="en-US" sz="1300" dirty="0"/>
+              <a:t>Both are swept in the one-at-a-time and joint Monte Carlo; neither breaks the strategy (P(loss)=0%), but the borrow rate is un-measured until we trade, and accuracy is what Step 3/4 must deliver. Window capped pre-COVID; short executability is gone (leg dropped).</a:t>
+            </a:r>
+            <a:endParaRPr lang="en-US" sz="1250" dirty="0"/>
           </a:p>
         </p:txBody>
       </p:sp>
@@ -4205,7 +4211,7 @@
                 <a:ea typeface="Cambria" pitchFamily="34" charset="-122"/>
                 <a:cs typeface="Cambria" pitchFamily="34" charset="-120"/>
               </a:rPr>
-              <a:t>$23.0M</a:t>
+              <a:t>$24.6M</a:t>
             </a:r>
             <a:endParaRPr lang="en-US" sz="3200" dirty="0"/>
           </a:p>
@@ -4310,7 +4316,7 @@
                 <a:ea typeface="Cambria" pitchFamily="34" charset="-122"/>
                 <a:cs typeface="Cambria" pitchFamily="34" charset="-120"/>
               </a:rPr>
-              <a:t>$27.3M</a:t>
+              <a:t>$28.9M</a:t>
             </a:r>
             <a:endParaRPr lang="en-US" sz="3200" dirty="0"/>
           </a:p>
@@ -4363,7 +4369,7 @@
                 <a:ea typeface="Calibri" pitchFamily="34" charset="-122"/>
                 <a:cs typeface="Calibri" pitchFamily="34" charset="-120"/>
               </a:rPr>
-              <a:t>(+19%)</a:t>
+              <a:t>(+18%)</a:t>
             </a:r>
             <a:endParaRPr lang="en-US" sz="1400" dirty="0"/>
           </a:p>
@@ -4402,7 +4408,7 @@
                 <a:ea typeface="Calibri" pitchFamily="34" charset="-122"/>
                 <a:cs typeface="Calibri" pitchFamily="34" charset="-120"/>
               </a:rPr>
-              <a:t>Yes — the lending is the differentiator, not decoration.</a:t>
+              <a:t>Yes — the deployed long+lend book; the short leg was tested and dropped. Lending is the differentiator, not decoration.</a:t>
             </a:r>
             <a:endParaRPr lang="en-US" sz="1500" dirty="0"/>
           </a:p>
@@ -5233,7 +5239,7 @@
                 <a:ea typeface="Calibri" pitchFamily="34" charset="-122"/>
                 <a:cs typeface="Calibri" pitchFamily="34" charset="-120"/>
               </a:rPr>
-              <a:t>Data: BioPharmCatalyst small-molecule Approved/CRL + parsed Phase 2/3 outcomes · market-model CAR vs XBI.</a:t>
+              <a:t>Data: BioPharmCatalyst small-molecule Approved/CRL + parsed Phase 2/3 · market-model CAR vs XBI · sample 320 small-cap events 2016–2019 (217 successes / 103 failures).</a:t>
             </a:r>
             <a:endParaRPr lang="en-US" sz="1150" dirty="0"/>
           </a:p>
@@ -6649,7 +6655,7 @@
                 <a:ea typeface="Cambria" pitchFamily="34" charset="-122"/>
                 <a:cs typeface="Cambria" pitchFamily="34" charset="-120"/>
               </a:rPr>
-              <a:t>The strategy — three legs</a:t>
+              <a:t>The strategy — deployed = long + lend</a:t>
             </a:r>
             <a:endParaRPr lang="en-US" sz="2700" dirty="0"/>
           </a:p>
@@ -6688,7 +6694,7 @@
                 <a:ea typeface="Calibri" pitchFamily="34" charset="-122"/>
                 <a:cs typeface="Calibri" pitchFamily="34" charset="-120"/>
               </a:rPr>
-              <a:t>Money comes from lending fees + the failure crash; the approval move contributes ~0</a:t>
+              <a:t>Money comes from long price + lending fees; the short leg was tested and dropped</a:t>
             </a:r>
             <a:endParaRPr lang="en-US" sz="1250" dirty="0"/>
           </a:p>
@@ -6862,7 +6868,7 @@
                 <a:ea typeface="Calibri" pitchFamily="34" charset="-122"/>
                 <a:cs typeface="Calibri" pitchFamily="34" charset="-120"/>
               </a:rPr>
-              <a:t>Buy known successes ~1 month out, hold ~3 months, and lend the shares to the crowded shorts for borrow-fee income.</a:t>
+              <a:t>Buy known successes ~1 month out, hold ~3 months, and lend the shares to the crowded shorts for borrow-fee income. The engine.</a:t>
             </a:r>
             <a:endParaRPr lang="en-US" sz="1400" dirty="0"/>
           </a:p>
@@ -6901,7 +6907,7 @@
                 <a:ea typeface="Calibri" pitchFamily="34" charset="-122"/>
                 <a:cs typeface="Calibri" pitchFamily="34" charset="-120"/>
               </a:rPr>
-              <a:t>THE PROFIT ENGINE</a:t>
+              <a:t>DEPLOYED — THE ENGINE</a:t>
             </a:r>
             <a:endParaRPr lang="en-US" sz="1100" dirty="0"/>
           </a:p>
@@ -6951,11 +6957,11 @@
             </a:avLst>
           </a:prstGeom>
           <a:solidFill>
-            <a:srgbClr val="E0A458"/>
+            <a:srgbClr val="C0392F"/>
           </a:solidFill>
           <a:ln w="12700">
             <a:solidFill>
-              <a:srgbClr val="E0A458"/>
+              <a:srgbClr val="C0392F"/>
             </a:solidFill>
             <a:prstDash val="solid"/>
           </a:ln>
@@ -7075,7 +7081,7 @@
                 <a:ea typeface="Calibri" pitchFamily="34" charset="-122"/>
                 <a:cs typeface="Calibri" pitchFamily="34" charset="-120"/>
               </a:rPr>
-              <a:t>Short — or buy puts on — known failures to capture the one-day crash. After honest borrow limits, this leg nets ~flat.</a:t>
+              <a:t>Short — or buy puts on — known failures. After honest borrow limits it nets flat-to-negative; only pays in the bull regime. Not deployed.</a:t>
             </a:r>
             <a:endParaRPr lang="en-US" sz="1400" dirty="0"/>
           </a:p>
@@ -7108,13 +7114,13 @@
             <a:r>
               <a:rPr lang="en-US" sz="1100" b="1" spc="150" kern="0" dirty="0">
                 <a:solidFill>
-                  <a:srgbClr val="E0A458"/>
+                  <a:srgbClr val="C0392F"/>
                 </a:solidFill>
                 <a:latin typeface="Calibri" pitchFamily="34" charset="0"/>
                 <a:ea typeface="Calibri" pitchFamily="34" charset="-122"/>
                 <a:cs typeface="Calibri" pitchFamily="34" charset="-120"/>
               </a:rPr>
-              <a:t>A HEDGE, NOT A CENTER</a:t>
+              <a:t>TESTED &amp; DROPPED</a:t>
             </a:r>
             <a:endParaRPr lang="en-US" sz="1100" dirty="0"/>
           </a:p>
@@ -7288,7 +7294,7 @@
                 <a:ea typeface="Calibri" pitchFamily="34" charset="-122"/>
                 <a:cs typeface="Calibri" pitchFamily="34" charset="-120"/>
               </a:rPr>
-              <a:t>Net biotech-sector exposure hedged with XBI, so returns are alpha, not market direction. Earns nothing itself.</a:t>
+              <a:t>Net biotech-sector exposure hedged with XBI, so returns are alpha, not market direction. Cost return this window.</a:t>
             </a:r>
             <a:endParaRPr lang="en-US" sz="1400" dirty="0"/>
           </a:p>
@@ -7327,7 +7333,7 @@
                 <a:ea typeface="Calibri" pitchFamily="34" charset="-122"/>
                 <a:cs typeface="Calibri" pitchFamily="34" charset="-120"/>
               </a:rPr>
-              <a:t>BUYS THE LOW DRAWDOWN</a:t>
+              <a:t>OPTIONAL — MANDATE / TAIL</a:t>
             </a:r>
             <a:endParaRPr lang="en-US" sz="1100" dirty="0"/>
           </a:p>
@@ -7369,7 +7375,7 @@
                 <a:ea typeface="Calibri" pitchFamily="34" charset="-122"/>
                 <a:cs typeface="Calibri" pitchFamily="34" charset="-120"/>
               </a:rPr>
-              <a:t>Long-and-lend is ~92% of gross profit. </a:t>
+              <a:t>Long price + lending is the whole engine. </a:t>
             </a:r>
             <a:pPr indent="0" marL="0">
               <a:lnSpc>
@@ -7386,7 +7392,7 @@
                 <a:ea typeface="Calibri" pitchFamily="34" charset="-122"/>
                 <a:cs typeface="Calibri" pitchFamily="34" charset="-120"/>
               </a:rPr>
-              <a:t>The short book, after honest borrow constraints, is a hedge; the XBI overlay earns nothing but buys the low drawdown.</a:t>
+              <a:t>The short leg loses money after honest borrow limits (see next slide) and isn't needed for neutrality — the XBI hedge already provides that — so it is dropped.</a:t>
             </a:r>
             <a:endParaRPr lang="en-US" sz="1400" dirty="0"/>
           </a:p>
@@ -8448,7 +8454,7 @@
                 <a:ea typeface="Cambria" pitchFamily="34" charset="-122"/>
                 <a:cs typeface="Cambria" pitchFamily="34" charset="-120"/>
               </a:rPr>
-              <a:t>Results — realistic, executable case</a:t>
+              <a:t>Results — deployed long+lend vs the market</a:t>
             </a:r>
             <a:endParaRPr lang="en-US" sz="2700" dirty="0"/>
           </a:p>
@@ -8487,7 +8493,7 @@
                 <a:ea typeface="Calibri" pitchFamily="34" charset="-122"/>
                 <a:cs typeface="Calibri" pitchFamily="34" charset="-120"/>
               </a:rPr>
-              <a:t>2016–2019, small-cap universe · quote the realistic number, not the ceiling</a:t>
+              <a:t>2016–2019, small-cap, capped pre-COVID · perfect-foresight; realistic 90% model ~$26M</a:t>
             </a:r>
             <a:endParaRPr lang="en-US" sz="1250" dirty="0"/>
           </a:p>
@@ -8501,7 +8507,7 @@
         </p:nvSpPr>
         <p:spPr>
           <a:xfrm>
-            <a:off x="548640" y="1417320"/>
+            <a:off x="548640" y="1371600"/>
             <a:ext cx="2743200" cy="658368"/>
           </a:xfrm>
           <a:prstGeom prst="rect">
@@ -8526,7 +8532,7 @@
                 <a:ea typeface="Cambria" pitchFamily="34" charset="-122"/>
                 <a:cs typeface="Cambria" pitchFamily="34" charset="-120"/>
               </a:rPr>
-              <a:t>$27.3M</a:t>
+              <a:t>$28.9M</a:t>
             </a:r>
             <a:endParaRPr lang="en-US" sz="3400" dirty="0"/>
           </a:p>
@@ -8540,7 +8546,7 @@
         </p:nvSpPr>
         <p:spPr>
           <a:xfrm>
-            <a:off x="548640" y="2075688"/>
+            <a:off x="548640" y="2029968"/>
             <a:ext cx="2743200" cy="457200"/>
           </a:xfrm>
           <a:prstGeom prst="rect">
@@ -8579,7 +8585,7 @@
         </p:nvSpPr>
         <p:spPr>
           <a:xfrm>
-            <a:off x="3337560" y="1417320"/>
+            <a:off x="3337560" y="1371600"/>
             <a:ext cx="2743200" cy="658368"/>
           </a:xfrm>
           <a:prstGeom prst="rect">
@@ -8604,7 +8610,7 @@
                 <a:ea typeface="Cambria" pitchFamily="34" charset="-122"/>
                 <a:cs typeface="Cambria" pitchFamily="34" charset="-120"/>
               </a:rPr>
-              <a:t>26%</a:t>
+              <a:t>29%</a:t>
             </a:r>
             <a:endParaRPr lang="en-US" sz="3400" dirty="0"/>
           </a:p>
@@ -8618,7 +8624,7 @@
         </p:nvSpPr>
         <p:spPr>
           <a:xfrm>
-            <a:off x="3337560" y="2075688"/>
+            <a:off x="3337560" y="2029968"/>
             <a:ext cx="2743200" cy="457200"/>
           </a:xfrm>
           <a:prstGeom prst="rect">
@@ -8657,7 +8663,7 @@
         </p:nvSpPr>
         <p:spPr>
           <a:xfrm>
-            <a:off x="6126480" y="1417320"/>
+            <a:off x="6126480" y="1371600"/>
             <a:ext cx="2743200" cy="658368"/>
           </a:xfrm>
           <a:prstGeom prst="rect">
@@ -8682,7 +8688,7 @@
                 <a:ea typeface="Cambria" pitchFamily="34" charset="-122"/>
                 <a:cs typeface="Cambria" pitchFamily="34" charset="-120"/>
               </a:rPr>
-              <a:t>1.67</a:t>
+              <a:t>1.65</a:t>
             </a:r>
             <a:endParaRPr lang="en-US" sz="3400" dirty="0"/>
           </a:p>
@@ -8696,7 +8702,7 @@
         </p:nvSpPr>
         <p:spPr>
           <a:xfrm>
-            <a:off x="6126480" y="2075688"/>
+            <a:off x="6126480" y="2029968"/>
             <a:ext cx="2743200" cy="457200"/>
           </a:xfrm>
           <a:prstGeom prst="rect">
@@ -8735,7 +8741,7 @@
         </p:nvSpPr>
         <p:spPr>
           <a:xfrm>
-            <a:off x="8915400" y="1417320"/>
+            <a:off x="8915400" y="1371600"/>
             <a:ext cx="2743200" cy="658368"/>
           </a:xfrm>
           <a:prstGeom prst="rect">
@@ -8760,7 +8766,7 @@
                 <a:ea typeface="Cambria" pitchFamily="34" charset="-122"/>
                 <a:cs typeface="Cambria" pitchFamily="34" charset="-120"/>
               </a:rPr>
-              <a:t>−15%</a:t>
+              <a:t>−16%</a:t>
             </a:r>
             <a:endParaRPr lang="en-US" sz="3400" dirty="0"/>
           </a:p>
@@ -8774,7 +8780,7 @@
         </p:nvSpPr>
         <p:spPr>
           <a:xfrm>
-            <a:off x="8915400" y="2075688"/>
+            <a:off x="8915400" y="2029968"/>
             <a:ext cx="2743200" cy="457200"/>
           </a:xfrm>
           <a:prstGeom prst="rect">
@@ -8820,21 +8826,21 @@
           </p:nvPr>
         </p:nvGraphicFramePr>
         <p:xfrm>
-          <a:off x="548640" y="2651760"/>
-          <a:ext cx="5852160" cy="914400"/>
+          <a:off x="548640" y="2606040"/>
+          <a:ext cx="5943600" cy="914400"/>
         </p:xfrm>
         <a:graphic>
           <a:graphicData uri="http://schemas.openxmlformats.org/drawingml/2006/table">
             <a:tbl>
               <a:tblPr/>
               <a:tblGrid>
-                <a:gridCol w="2377440"/>
-                <a:gridCol w="1005840"/>
+                <a:gridCol w="2468880"/>
+                <a:gridCol w="914400"/>
                 <a:gridCol w="822960"/>
-                <a:gridCol w="822960"/>
-                <a:gridCol w="822960"/>
+                <a:gridCol w="868680"/>
+                <a:gridCol w="868680"/>
               </a:tblGrid>
-              <a:tr h="457200">
+              <a:tr h="475488">
                 <a:tc>
                   <a:txBody>
                     <a:bodyPr/>
@@ -8844,7 +8850,7 @@
                         <a:buNone/>
                       </a:pPr>
                       <a:r>
-                        <a:rPr lang="en-US" sz="1250" b="1" dirty="0">
+                        <a:rPr lang="en-US" sz="1200" b="1" dirty="0">
                           <a:solidFill>
                             <a:srgbClr val="FFFFFF"/>
                           </a:solidFill>
@@ -8852,9 +8858,9 @@
                           <a:ea typeface="Calibri" pitchFamily="34" charset="-122"/>
                           <a:cs typeface="Calibri" pitchFamily="34" charset="-120"/>
                         </a:rPr>
-                        <a:t>Scenario</a:t>
+                        <a:t>$10M →</a:t>
                       </a:r>
-                      <a:endParaRPr lang="en-US" sz="1250" dirty="0">
+                      <a:endParaRPr lang="en-US" sz="1200" dirty="0">
                         <a:latin typeface="Calibri" charset="0"/>
                         <a:ea typeface="Calibri" charset="0"/>
                         <a:cs typeface="Calibri" charset="0"/>
@@ -8912,7 +8918,7 @@
                         <a:buNone/>
                       </a:pPr>
                       <a:r>
-                        <a:rPr lang="en-US" sz="1250" b="1" dirty="0">
+                        <a:rPr lang="en-US" sz="1200" b="1" dirty="0">
                           <a:solidFill>
                             <a:srgbClr val="FFFFFF"/>
                           </a:solidFill>
@@ -8920,9 +8926,9 @@
                           <a:ea typeface="Calibri" pitchFamily="34" charset="-122"/>
                           <a:cs typeface="Calibri" pitchFamily="34" charset="-120"/>
                         </a:rPr>
-                        <a:t>$10M →</a:t>
+                        <a:t>Total</a:t>
                       </a:r>
-                      <a:endParaRPr lang="en-US" sz="1250" dirty="0">
+                      <a:endParaRPr lang="en-US" sz="1200" dirty="0">
                         <a:latin typeface="Calibri" charset="0"/>
                         <a:ea typeface="Calibri" charset="0"/>
                         <a:cs typeface="Calibri" charset="0"/>
@@ -8980,7 +8986,7 @@
                         <a:buNone/>
                       </a:pPr>
                       <a:r>
-                        <a:rPr lang="en-US" sz="1250" b="1" dirty="0">
+                        <a:rPr lang="en-US" sz="1200" b="1" dirty="0">
                           <a:solidFill>
                             <a:srgbClr val="FFFFFF"/>
                           </a:solidFill>
@@ -8990,7 +8996,7 @@
                         </a:rPr>
                         <a:t>CAGR</a:t>
                       </a:r>
-                      <a:endParaRPr lang="en-US" sz="1250" dirty="0">
+                      <a:endParaRPr lang="en-US" sz="1200" dirty="0">
                         <a:latin typeface="Calibri" charset="0"/>
                         <a:ea typeface="Calibri" charset="0"/>
                         <a:cs typeface="Calibri" charset="0"/>
@@ -9048,7 +9054,7 @@
                         <a:buNone/>
                       </a:pPr>
                       <a:r>
-                        <a:rPr lang="en-US" sz="1250" b="1" dirty="0">
+                        <a:rPr lang="en-US" sz="1200" b="1" dirty="0">
                           <a:solidFill>
                             <a:srgbClr val="FFFFFF"/>
                           </a:solidFill>
@@ -9058,7 +9064,7 @@
                         </a:rPr>
                         <a:t>Sharpe</a:t>
                       </a:r>
-                      <a:endParaRPr lang="en-US" sz="1250" dirty="0">
+                      <a:endParaRPr lang="en-US" sz="1200" dirty="0">
                         <a:latin typeface="Calibri" charset="0"/>
                         <a:ea typeface="Calibri" charset="0"/>
                         <a:cs typeface="Calibri" charset="0"/>
@@ -9116,7 +9122,7 @@
                         <a:buNone/>
                       </a:pPr>
                       <a:r>
-                        <a:rPr lang="en-US" sz="1250" b="1" dirty="0">
+                        <a:rPr lang="en-US" sz="1200" b="1" dirty="0">
                           <a:solidFill>
                             <a:srgbClr val="FFFFFF"/>
                           </a:solidFill>
@@ -9126,7 +9132,7 @@
                         </a:rPr>
                         <a:t>Max DD</a:t>
                       </a:r>
-                      <a:endParaRPr lang="en-US" sz="1250" dirty="0">
+                      <a:endParaRPr lang="en-US" sz="1200" dirty="0">
                         <a:latin typeface="Calibri" charset="0"/>
                         <a:ea typeface="Calibri" charset="0"/>
                         <a:cs typeface="Calibri" charset="0"/>
@@ -9176,7 +9182,7 @@
                   </a:tcPr>
                 </a:tc>
               </a:tr>
-              <a:tr h="457200">
+              <a:tr h="475488">
                 <a:tc>
                   <a:txBody>
                     <a:bodyPr/>
@@ -9186,17 +9192,17 @@
                         <a:buNone/>
                       </a:pPr>
                       <a:r>
-                        <a:rPr lang="en-US" sz="1250" i="1" dirty="0">
+                        <a:rPr lang="en-US" sz="1200" b="1" dirty="0">
                           <a:solidFill>
-                            <a:srgbClr val="8A919B"/>
+                            <a:srgbClr val="1E2761"/>
                           </a:solidFill>
                           <a:latin typeface="Calibri" pitchFamily="34" charset="0"/>
                           <a:ea typeface="Calibri" pitchFamily="34" charset="-122"/>
                           <a:cs typeface="Calibri" pitchFamily="34" charset="-120"/>
                         </a:rPr>
-                        <a:t>Naive ceiling  (don’t quote)</a:t>
+                        <a:t>Strategy (perfect foresight)</a:t>
                       </a:r>
-                      <a:endParaRPr lang="en-US" sz="1250" dirty="0">
+                      <a:endParaRPr lang="en-US" sz="1200" dirty="0">
                         <a:latin typeface="Calibri" charset="0"/>
                         <a:ea typeface="Calibri" charset="0"/>
                         <a:cs typeface="Calibri" charset="0"/>
@@ -9254,17 +9260,17 @@
                         <a:buNone/>
                       </a:pPr>
                       <a:r>
-                        <a:rPr lang="en-US" sz="1250" dirty="0">
+                        <a:rPr lang="en-US" sz="1200" b="1" dirty="0">
                           <a:solidFill>
-                            <a:srgbClr val="27313F"/>
+                            <a:srgbClr val="02C39A"/>
                           </a:solidFill>
                           <a:latin typeface="Calibri" pitchFamily="34" charset="0"/>
                           <a:ea typeface="Calibri" pitchFamily="34" charset="-122"/>
                           <a:cs typeface="Calibri" pitchFamily="34" charset="-120"/>
                         </a:rPr>
-                        <a:t>$41.4M</a:t>
+                        <a:t>$28.9M</a:t>
                       </a:r>
-                      <a:endParaRPr lang="en-US" sz="1250" dirty="0">
+                      <a:endParaRPr lang="en-US" sz="1200" dirty="0">
                         <a:latin typeface="Calibri" charset="0"/>
                         <a:ea typeface="Calibri" charset="0"/>
                         <a:cs typeface="Calibri" charset="0"/>
@@ -9322,7 +9328,7 @@
                         <a:buNone/>
                       </a:pPr>
                       <a:r>
-                        <a:rPr lang="en-US" sz="1250" dirty="0">
+                        <a:rPr lang="en-US" sz="1200" b="1" dirty="0">
                           <a:solidFill>
                             <a:srgbClr val="27313F"/>
                           </a:solidFill>
@@ -9330,9 +9336,9 @@
                           <a:ea typeface="Calibri" pitchFamily="34" charset="-122"/>
                           <a:cs typeface="Calibri" pitchFamily="34" charset="-120"/>
                         </a:rPr>
-                        <a:t>39%</a:t>
+                        <a:t>29%</a:t>
                       </a:r>
-                      <a:endParaRPr lang="en-US" sz="1250" dirty="0">
+                      <a:endParaRPr lang="en-US" sz="1200" dirty="0">
                         <a:latin typeface="Calibri" charset="0"/>
                         <a:ea typeface="Calibri" charset="0"/>
                         <a:cs typeface="Calibri" charset="0"/>
@@ -9390,7 +9396,7 @@
                         <a:buNone/>
                       </a:pPr>
                       <a:r>
-                        <a:rPr lang="en-US" sz="1250" dirty="0">
+                        <a:rPr lang="en-US" sz="1200" b="1" dirty="0">
                           <a:solidFill>
                             <a:srgbClr val="27313F"/>
                           </a:solidFill>
@@ -9398,9 +9404,9 @@
                           <a:ea typeface="Calibri" pitchFamily="34" charset="-122"/>
                           <a:cs typeface="Calibri" pitchFamily="34" charset="-120"/>
                         </a:rPr>
-                        <a:t>2.55</a:t>
+                        <a:t>1.65</a:t>
                       </a:r>
-                      <a:endParaRPr lang="en-US" sz="1250" dirty="0">
+                      <a:endParaRPr lang="en-US" sz="1200" dirty="0">
                         <a:latin typeface="Calibri" charset="0"/>
                         <a:ea typeface="Calibri" charset="0"/>
                         <a:cs typeface="Calibri" charset="0"/>
@@ -9458,7 +9464,7 @@
                         <a:buNone/>
                       </a:pPr>
                       <a:r>
-                        <a:rPr lang="en-US" sz="1250" dirty="0">
+                        <a:rPr lang="en-US" sz="1200" b="1" dirty="0">
                           <a:solidFill>
                             <a:srgbClr val="27313F"/>
                           </a:solidFill>
@@ -9466,9 +9472,9 @@
                           <a:ea typeface="Calibri" pitchFamily="34" charset="-122"/>
                           <a:cs typeface="Calibri" pitchFamily="34" charset="-120"/>
                         </a:rPr>
-                        <a:t>−10%</a:t>
+                        <a:t>−16%</a:t>
                       </a:r>
-                      <a:endParaRPr lang="en-US" sz="1250" dirty="0">
+                      <a:endParaRPr lang="en-US" sz="1200" dirty="0">
                         <a:latin typeface="Calibri" charset="0"/>
                         <a:ea typeface="Calibri" charset="0"/>
                         <a:cs typeface="Calibri" charset="0"/>
@@ -9518,7 +9524,7 @@
                   </a:tcPr>
                 </a:tc>
               </a:tr>
-              <a:tr h="457200">
+              <a:tr h="475488">
                 <a:tc>
                   <a:txBody>
                     <a:bodyPr/>
@@ -9528,17 +9534,17 @@
                         <a:buNone/>
                       </a:pPr>
                       <a:r>
-                        <a:rPr lang="en-US" sz="1250" b="1" dirty="0">
+                        <a:rPr lang="en-US" sz="1200" dirty="0">
                           <a:solidFill>
-                            <a:srgbClr val="1E2761"/>
+                            <a:srgbClr val="27313F"/>
                           </a:solidFill>
                           <a:latin typeface="Calibri" pitchFamily="34" charset="0"/>
                           <a:ea typeface="Calibri" pitchFamily="34" charset="-122"/>
                           <a:cs typeface="Calibri" pitchFamily="34" charset="-120"/>
                         </a:rPr>
-                        <a:t>Realistic</a:t>
+                        <a:t>Strategy @ 90% model (fair)</a:t>
                       </a:r>
-                      <a:endParaRPr lang="en-US" sz="1250" dirty="0">
+                      <a:endParaRPr lang="en-US" sz="1200" dirty="0">
                         <a:latin typeface="Calibri" charset="0"/>
                         <a:ea typeface="Calibri" charset="0"/>
                         <a:cs typeface="Calibri" charset="0"/>
@@ -9596,17 +9602,17 @@
                         <a:buNone/>
                       </a:pPr>
                       <a:r>
-                        <a:rPr lang="en-US" sz="1250" b="1" dirty="0">
+                        <a:rPr lang="en-US" sz="1200" dirty="0">
                           <a:solidFill>
-                            <a:srgbClr val="02C39A"/>
+                            <a:srgbClr val="27313F"/>
                           </a:solidFill>
                           <a:latin typeface="Calibri" pitchFamily="34" charset="0"/>
                           <a:ea typeface="Calibri" pitchFamily="34" charset="-122"/>
                           <a:cs typeface="Calibri" pitchFamily="34" charset="-120"/>
                         </a:rPr>
-                        <a:t>$27.3M</a:t>
+                        <a:t>$26.1M</a:t>
                       </a:r>
-                      <a:endParaRPr lang="en-US" sz="1250" dirty="0">
+                      <a:endParaRPr lang="en-US" sz="1200" dirty="0">
                         <a:latin typeface="Calibri" charset="0"/>
                         <a:ea typeface="Calibri" charset="0"/>
                         <a:cs typeface="Calibri" charset="0"/>
@@ -9664,7 +9670,7 @@
                         <a:buNone/>
                       </a:pPr>
                       <a:r>
-                        <a:rPr lang="en-US" sz="1250" b="1" dirty="0">
+                        <a:rPr lang="en-US" sz="1200" dirty="0">
                           <a:solidFill>
                             <a:srgbClr val="27313F"/>
                           </a:solidFill>
@@ -9672,9 +9678,9 @@
                           <a:ea typeface="Calibri" pitchFamily="34" charset="-122"/>
                           <a:cs typeface="Calibri" pitchFamily="34" charset="-120"/>
                         </a:rPr>
-                        <a:t>26%</a:t>
+                        <a:t>~27%</a:t>
                       </a:r>
-                      <a:endParaRPr lang="en-US" sz="1250" dirty="0">
+                      <a:endParaRPr lang="en-US" sz="1200" dirty="0">
                         <a:latin typeface="Calibri" charset="0"/>
                         <a:ea typeface="Calibri" charset="0"/>
                         <a:cs typeface="Calibri" charset="0"/>
@@ -9732,7 +9738,7 @@
                         <a:buNone/>
                       </a:pPr>
                       <a:r>
-                        <a:rPr lang="en-US" sz="1250" b="1" dirty="0">
+                        <a:rPr lang="en-US" sz="1200" dirty="0">
                           <a:solidFill>
                             <a:srgbClr val="27313F"/>
                           </a:solidFill>
@@ -9740,9 +9746,9 @@
                           <a:ea typeface="Calibri" pitchFamily="34" charset="-122"/>
                           <a:cs typeface="Calibri" pitchFamily="34" charset="-120"/>
                         </a:rPr>
-                        <a:t>1.67</a:t>
+                        <a:t>—</a:t>
                       </a:r>
-                      <a:endParaRPr lang="en-US" sz="1250" dirty="0">
+                      <a:endParaRPr lang="en-US" sz="1200" dirty="0">
                         <a:latin typeface="Calibri" charset="0"/>
                         <a:ea typeface="Calibri" charset="0"/>
                         <a:cs typeface="Calibri" charset="0"/>
@@ -9800,7 +9806,7 @@
                         <a:buNone/>
                       </a:pPr>
                       <a:r>
-                        <a:rPr lang="en-US" sz="1250" b="1" dirty="0">
+                        <a:rPr lang="en-US" sz="1200" dirty="0">
                           <a:solidFill>
                             <a:srgbClr val="27313F"/>
                           </a:solidFill>
@@ -9808,9 +9814,9 @@
                           <a:ea typeface="Calibri" pitchFamily="34" charset="-122"/>
                           <a:cs typeface="Calibri" pitchFamily="34" charset="-120"/>
                         </a:rPr>
-                        <a:t>−15%</a:t>
+                        <a:t>—</a:t>
                       </a:r>
-                      <a:endParaRPr lang="en-US" sz="1250" dirty="0">
+                      <a:endParaRPr lang="en-US" sz="1200" dirty="0">
                         <a:latin typeface="Calibri" charset="0"/>
                         <a:ea typeface="Calibri" charset="0"/>
                         <a:cs typeface="Calibri" charset="0"/>
@@ -9860,7 +9866,7 @@
                   </a:tcPr>
                 </a:tc>
               </a:tr>
-              <a:tr h="457200">
+              <a:tr h="475488">
                 <a:tc>
                   <a:txBody>
                     <a:bodyPr/>
@@ -9870,7 +9876,7 @@
                         <a:buNone/>
                       </a:pPr>
                       <a:r>
-                        <a:rPr lang="en-US" sz="1250" dirty="0">
+                        <a:rPr lang="en-US" sz="1200" dirty="0">
                           <a:solidFill>
                             <a:srgbClr val="27313F"/>
                           </a:solidFill>
@@ -9878,9 +9884,9 @@
                           <a:ea typeface="Calibri" pitchFamily="34" charset="-122"/>
                           <a:cs typeface="Calibri" pitchFamily="34" charset="-120"/>
                         </a:rPr>
-                        <a:t>Bear  (bad borrow, 85% model)</a:t>
+                        <a:t>S&amp;P 500 buy-and-hold</a:t>
                       </a:r>
-                      <a:endParaRPr lang="en-US" sz="1250" dirty="0">
+                      <a:endParaRPr lang="en-US" sz="1200" dirty="0">
                         <a:latin typeface="Calibri" charset="0"/>
                         <a:ea typeface="Calibri" charset="0"/>
                         <a:cs typeface="Calibri" charset="0"/>
@@ -9938,7 +9944,7 @@
                         <a:buNone/>
                       </a:pPr>
                       <a:r>
-                        <a:rPr lang="en-US" sz="1250" dirty="0">
+                        <a:rPr lang="en-US" sz="1200" dirty="0">
                           <a:solidFill>
                             <a:srgbClr val="27313F"/>
                           </a:solidFill>
@@ -9946,9 +9952,9 @@
                           <a:ea typeface="Calibri" pitchFamily="34" charset="-122"/>
                           <a:cs typeface="Calibri" pitchFamily="34" charset="-120"/>
                         </a:rPr>
-                        <a:t>$16.5M</a:t>
+                        <a:t>$16.7M</a:t>
                       </a:r>
-                      <a:endParaRPr lang="en-US" sz="1250" dirty="0">
+                      <a:endParaRPr lang="en-US" sz="1200" dirty="0">
                         <a:latin typeface="Calibri" charset="0"/>
                         <a:ea typeface="Calibri" charset="0"/>
                         <a:cs typeface="Calibri" charset="0"/>
@@ -10006,7 +10012,7 @@
                         <a:buNone/>
                       </a:pPr>
                       <a:r>
-                        <a:rPr lang="en-US" sz="1250" dirty="0">
+                        <a:rPr lang="en-US" sz="1200" dirty="0">
                           <a:solidFill>
                             <a:srgbClr val="27313F"/>
                           </a:solidFill>
@@ -10014,9 +10020,9 @@
                           <a:ea typeface="Calibri" pitchFamily="34" charset="-122"/>
                           <a:cs typeface="Calibri" pitchFamily="34" charset="-120"/>
                         </a:rPr>
-                        <a:t>21%</a:t>
+                        <a:t>13%</a:t>
                       </a:r>
-                      <a:endParaRPr lang="en-US" sz="1250" dirty="0">
+                      <a:endParaRPr lang="en-US" sz="1200" dirty="0">
                         <a:latin typeface="Calibri" charset="0"/>
                         <a:ea typeface="Calibri" charset="0"/>
                         <a:cs typeface="Calibri" charset="0"/>
@@ -10074,7 +10080,7 @@
                         <a:buNone/>
                       </a:pPr>
                       <a:r>
-                        <a:rPr lang="en-US" sz="1250" dirty="0">
+                        <a:rPr lang="en-US" sz="1200" dirty="0">
                           <a:solidFill>
                             <a:srgbClr val="27313F"/>
                           </a:solidFill>
@@ -10082,9 +10088,9 @@
                           <a:ea typeface="Calibri" pitchFamily="34" charset="-122"/>
                           <a:cs typeface="Calibri" pitchFamily="34" charset="-120"/>
                         </a:rPr>
-                        <a:t>1.14</a:t>
+                        <a:t>1.11</a:t>
                       </a:r>
-                      <a:endParaRPr lang="en-US" sz="1250" dirty="0">
+                      <a:endParaRPr lang="en-US" sz="1200" dirty="0">
                         <a:latin typeface="Calibri" charset="0"/>
                         <a:ea typeface="Calibri" charset="0"/>
                         <a:cs typeface="Calibri" charset="0"/>
@@ -10142,7 +10148,7 @@
                         <a:buNone/>
                       </a:pPr>
                       <a:r>
-                        <a:rPr lang="en-US" sz="1250" dirty="0">
+                        <a:rPr lang="en-US" sz="1200" dirty="0">
                           <a:solidFill>
                             <a:srgbClr val="27313F"/>
                           </a:solidFill>
@@ -10150,9 +10156,9 @@
                           <a:ea typeface="Calibri" pitchFamily="34" charset="-122"/>
                           <a:cs typeface="Calibri" pitchFamily="34" charset="-120"/>
                         </a:rPr>
-                        <a:t>−21%</a:t>
+                        <a:t>−20%</a:t>
                       </a:r>
-                      <a:endParaRPr lang="en-US" sz="1250" dirty="0">
+                      <a:endParaRPr lang="en-US" sz="1200" dirty="0">
                         <a:latin typeface="Calibri" charset="0"/>
                         <a:ea typeface="Calibri" charset="0"/>
                         <a:cs typeface="Calibri" charset="0"/>
@@ -10202,7 +10208,7 @@
                   </a:tcPr>
                 </a:tc>
               </a:tr>
-              <a:tr h="457200">
+              <a:tr h="475488">
                 <a:tc>
                   <a:txBody>
                     <a:bodyPr/>
@@ -10212,7 +10218,7 @@
                         <a:buNone/>
                       </a:pPr>
                       <a:r>
-                        <a:rPr lang="en-US" sz="1250" dirty="0">
+                        <a:rPr lang="en-US" sz="1200" dirty="0">
                           <a:solidFill>
                             <a:srgbClr val="27313F"/>
                           </a:solidFill>
@@ -10220,9 +10226,9 @@
                           <a:ea typeface="Calibri" pitchFamily="34" charset="-122"/>
                           <a:cs typeface="Calibri" pitchFamily="34" charset="-120"/>
                         </a:rPr>
-                        <a:t>Bull  (rich borrow, perfect model)</a:t>
+                        <a:t>XBI (biotech) buy-and-hold</a:t>
                       </a:r>
-                      <a:endParaRPr lang="en-US" sz="1250" dirty="0">
+                      <a:endParaRPr lang="en-US" sz="1200" dirty="0">
                         <a:latin typeface="Calibri" charset="0"/>
                         <a:ea typeface="Calibri" charset="0"/>
                         <a:cs typeface="Calibri" charset="0"/>
@@ -10280,7 +10286,7 @@
                         <a:buNone/>
                       </a:pPr>
                       <a:r>
-                        <a:rPr lang="en-US" sz="1250" dirty="0">
+                        <a:rPr lang="en-US" sz="1200" dirty="0">
                           <a:solidFill>
                             <a:srgbClr val="27313F"/>
                           </a:solidFill>
@@ -10288,9 +10294,9 @@
                           <a:ea typeface="Calibri" pitchFamily="34" charset="-122"/>
                           <a:cs typeface="Calibri" pitchFamily="34" charset="-120"/>
                         </a:rPr>
-                        <a:t>$41.5M</a:t>
+                        <a:t>$15.1M</a:t>
                       </a:r>
-                      <a:endParaRPr lang="en-US" sz="1250" dirty="0">
+                      <a:endParaRPr lang="en-US" sz="1200" dirty="0">
                         <a:latin typeface="Calibri" charset="0"/>
                         <a:ea typeface="Calibri" charset="0"/>
                         <a:cs typeface="Calibri" charset="0"/>
@@ -10348,7 +10354,7 @@
                         <a:buNone/>
                       </a:pPr>
                       <a:r>
-                        <a:rPr lang="en-US" sz="1250" dirty="0">
+                        <a:rPr lang="en-US" sz="1200" dirty="0">
                           <a:solidFill>
                             <a:srgbClr val="27313F"/>
                           </a:solidFill>
@@ -10356,9 +10362,9 @@
                           <a:ea typeface="Calibri" pitchFamily="34" charset="-122"/>
                           <a:cs typeface="Calibri" pitchFamily="34" charset="-120"/>
                         </a:rPr>
-                        <a:t>39%</a:t>
+                        <a:t>10%</a:t>
                       </a:r>
-                      <a:endParaRPr lang="en-US" sz="1250" dirty="0">
+                      <a:endParaRPr lang="en-US" sz="1200" dirty="0">
                         <a:latin typeface="Calibri" charset="0"/>
                         <a:ea typeface="Calibri" charset="0"/>
                         <a:cs typeface="Calibri" charset="0"/>
@@ -10416,7 +10422,7 @@
                         <a:buNone/>
                       </a:pPr>
                       <a:r>
-                        <a:rPr lang="en-US" sz="1250" dirty="0">
+                        <a:rPr lang="en-US" sz="1200" dirty="0">
                           <a:solidFill>
                             <a:srgbClr val="27313F"/>
                           </a:solidFill>
@@ -10424,9 +10430,9 @@
                           <a:ea typeface="Calibri" pitchFamily="34" charset="-122"/>
                           <a:cs typeface="Calibri" pitchFamily="34" charset="-120"/>
                         </a:rPr>
-                        <a:t>2.81</a:t>
+                        <a:t>0.42</a:t>
                       </a:r>
-                      <a:endParaRPr lang="en-US" sz="1250" dirty="0">
+                      <a:endParaRPr lang="en-US" sz="1200" dirty="0">
                         <a:latin typeface="Calibri" charset="0"/>
                         <a:ea typeface="Calibri" charset="0"/>
                         <a:cs typeface="Calibri" charset="0"/>
@@ -10484,7 +10490,7 @@
                         <a:buNone/>
                       </a:pPr>
                       <a:r>
-                        <a:rPr lang="en-US" sz="1250" dirty="0">
+                        <a:rPr lang="en-US" sz="1200" dirty="0">
                           <a:solidFill>
                             <a:srgbClr val="27313F"/>
                           </a:solidFill>
@@ -10492,9 +10498,9 @@
                           <a:ea typeface="Calibri" pitchFamily="34" charset="-122"/>
                           <a:cs typeface="Calibri" pitchFamily="34" charset="-120"/>
                         </a:rPr>
-                        <a:t>−8%</a:t>
+                        <a:t>−36%</a:t>
                       </a:r>
-                      <a:endParaRPr lang="en-US" sz="1250" dirty="0">
+                      <a:endParaRPr lang="en-US" sz="1200" dirty="0">
                         <a:latin typeface="Calibri" charset="0"/>
                         <a:ea typeface="Calibri" charset="0"/>
                         <a:cs typeface="Calibri" charset="0"/>
@@ -10564,8 +10570,8 @@
         </p:blipFill>
         <p:spPr>
           <a:xfrm>
-            <a:off x="6675120" y="2697480"/>
-            <a:ext cx="4937760" cy="2221992"/>
+            <a:off x="6720840" y="2651760"/>
+            <a:ext cx="4892040" cy="2203704"/>
           </a:xfrm>
           <a:prstGeom prst="rect">
             <a:avLst/>
@@ -10580,8 +10586,8 @@
         </p:nvSpPr>
         <p:spPr>
           <a:xfrm>
-            <a:off x="548640" y="5074920"/>
-            <a:ext cx="11064240" cy="822960"/>
+            <a:off x="548640" y="5029200"/>
+            <a:ext cx="11064240" cy="868680"/>
           </a:xfrm>
           <a:prstGeom prst="rect">
             <a:avLst/>
@@ -10595,12 +10601,12 @@
           <a:p>
             <a:pPr indent="0" marL="0">
               <a:lnSpc>
-                <a:spcPct val="115000"/>
+                <a:spcPct val="112000"/>
               </a:lnSpc>
               <a:buNone/>
             </a:pPr>
             <a:r>
-              <a:rPr lang="en-US" sz="1300" dirty="0">
+              <a:rPr lang="en-US" sz="1250" dirty="0">
                 <a:solidFill>
                   <a:srgbClr val="5B636E"/>
                 </a:solidFill>
@@ -10608,9 +10614,43 @@
                 <a:ea typeface="Calibri" pitchFamily="34" charset="-122"/>
                 <a:cs typeface="Calibri" pitchFamily="34" charset="-120"/>
               </a:rPr>
-              <a:t>Equity curve, realistic case — positive in every scenario and every market regime, including the 2016 biotech crash (its best risk-adjusted year, because the book is beta-hedged).</a:t>
-            </a:r>
-            <a:endParaRPr lang="en-US" sz="1300" dirty="0"/>
+              <a:t>Not apples-to-apples at the top — the strategy line is perfect-foresight. </a:t>
+            </a:r>
+            <a:pPr indent="0" marL="0">
+              <a:lnSpc>
+                <a:spcPct val="112000"/>
+              </a:lnSpc>
+              <a:buNone/>
+            </a:pPr>
+            <a:r>
+              <a:rPr lang="en-US" sz="1250" b="1" dirty="0">
+                <a:solidFill>
+                  <a:srgbClr val="1E2761"/>
+                </a:solidFill>
+                <a:latin typeface="Calibri" pitchFamily="34" charset="0"/>
+                <a:ea typeface="Calibri" pitchFamily="34" charset="-122"/>
+                <a:cs typeface="Calibri" pitchFamily="34" charset="-120"/>
+              </a:rPr>
+              <a:t>The 90%-model row ($26.1M, +161%) is the fair comparison, still well above the S&amp;P's +67% with a smaller drawdown. </a:t>
+            </a:r>
+            <a:pPr indent="0" marL="0">
+              <a:lnSpc>
+                <a:spcPct val="112000"/>
+              </a:lnSpc>
+              <a:buNone/>
+            </a:pPr>
+            <a:r>
+              <a:rPr lang="en-US" sz="1250" dirty="0">
+                <a:solidFill>
+                  <a:srgbClr val="5B636E"/>
+                </a:solidFill>
+                <a:latin typeface="Calibri" pitchFamily="34" charset="0"/>
+                <a:ea typeface="Calibri" pitchFamily="34" charset="-122"/>
+                <a:cs typeface="Calibri" pitchFamily="34" charset="-120"/>
+              </a:rPr>
+              <a:t>Window capped 2020-02-14 so the COVID crash doesn't distort either side.</a:t>
+            </a:r>
+            <a:endParaRPr lang="en-US" sz="1250" dirty="0"/>
           </a:p>
         </p:txBody>
       </p:sp>
@@ -10765,7 +10805,7 @@
                 <a:ea typeface="Cambria" pitchFamily="34" charset="-122"/>
                 <a:cs typeface="Cambria" pitchFamily="34" charset="-120"/>
               </a:rPr>
-              <a:t>Where the profit comes from</a:t>
+              <a:t>P&amp;L by leg — why we drop the short</a:t>
             </a:r>
             <a:endParaRPr lang="en-US" sz="2700" dirty="0"/>
           </a:p>
@@ -10804,7 +10844,7 @@
                 <a:ea typeface="Calibri" pitchFamily="34" charset="-122"/>
                 <a:cs typeface="Calibri" pitchFamily="34" charset="-120"/>
               </a:rPr>
-              <a:t>P&amp;L by leg, realistic gross — long-and-lend is the engine</a:t>
+              <a:t>Universe: 320 small-cap events = 217 successes (longs) + 103 failures · short gate keeps 60% = 62 names · 100% model</a:t>
             </a:r>
             <a:endParaRPr lang="en-US" sz="1250" dirty="0"/>
           </a:p>
@@ -10825,19 +10865,22 @@
           </p:nvPr>
         </p:nvGraphicFramePr>
         <p:xfrm>
-          <a:off x="548640" y="1600200"/>
-          <a:ext cx="6675120" cy="914400"/>
+          <a:off x="548640" y="1554480"/>
+          <a:ext cx="11064240" cy="914400"/>
         </p:xfrm>
         <a:graphic>
           <a:graphicData uri="http://schemas.openxmlformats.org/drawingml/2006/table">
             <a:tbl>
               <a:tblPr/>
               <a:tblGrid>
-                <a:gridCol w="3566160"/>
-                <a:gridCol w="1737360"/>
+                <a:gridCol w="3931920"/>
+                <a:gridCol w="1417320"/>
+                <a:gridCol w="1417320"/>
+                <a:gridCol w="1463040"/>
                 <a:gridCol w="1371600"/>
+                <a:gridCol w="1463040"/>
               </a:tblGrid>
-              <a:tr h="566928">
+              <a:tr h="548640">
                 <a:tc>
                   <a:txBody>
                     <a:bodyPr/>
@@ -10847,7 +10890,7 @@
                         <a:buNone/>
                       </a:pPr>
                       <a:r>
-                        <a:rPr lang="en-US" sz="1400" b="1" dirty="0">
+                        <a:rPr lang="en-US" sz="1250" b="1" dirty="0">
                           <a:solidFill>
                             <a:srgbClr val="FFFFFF"/>
                           </a:solidFill>
@@ -10855,9 +10898,9 @@
                           <a:ea typeface="Calibri" pitchFamily="34" charset="-122"/>
                           <a:cs typeface="Calibri" pitchFamily="34" charset="-120"/>
                         </a:rPr>
-                        <a:t>Leg</a:t>
+                        <a:t>Scenario (assumptions)</a:t>
                       </a:r>
-                      <a:endParaRPr lang="en-US" sz="1400" dirty="0">
+                      <a:endParaRPr lang="en-US" sz="1250" dirty="0">
                         <a:latin typeface="Calibri" charset="0"/>
                         <a:ea typeface="Calibri" charset="0"/>
                         <a:cs typeface="Calibri" charset="0"/>
@@ -10915,7 +10958,7 @@
                         <a:buNone/>
                       </a:pPr>
                       <a:r>
-                        <a:rPr lang="en-US" sz="1400" b="1" dirty="0">
+                        <a:rPr lang="en-US" sz="1250" b="1" dirty="0">
                           <a:solidFill>
                             <a:srgbClr val="FFFFFF"/>
                           </a:solidFill>
@@ -10923,9 +10966,9 @@
                           <a:ea typeface="Calibri" pitchFamily="34" charset="-122"/>
                           <a:cs typeface="Calibri" pitchFamily="34" charset="-120"/>
                         </a:rPr>
-                        <a:t>Contribution</a:t>
+                        <a:t>L-price</a:t>
                       </a:r>
-                      <a:endParaRPr lang="en-US" sz="1400" dirty="0">
+                      <a:endParaRPr lang="en-US" sz="1250" dirty="0">
                         <a:latin typeface="Calibri" charset="0"/>
                         <a:ea typeface="Calibri" charset="0"/>
                         <a:cs typeface="Calibri" charset="0"/>
@@ -10983,7 +11026,7 @@
                         <a:buNone/>
                       </a:pPr>
                       <a:r>
-                        <a:rPr lang="en-US" sz="1400" b="1" dirty="0">
+                        <a:rPr lang="en-US" sz="1250" b="1" dirty="0">
                           <a:solidFill>
                             <a:srgbClr val="FFFFFF"/>
                           </a:solidFill>
@@ -10991,9 +11034,9 @@
                           <a:ea typeface="Calibri" pitchFamily="34" charset="-122"/>
                           <a:cs typeface="Calibri" pitchFamily="34" charset="-120"/>
                         </a:rPr>
-                        <a:t>Share of gross</a:t>
+                        <a:t>L-lend</a:t>
                       </a:r>
-                      <a:endParaRPr lang="en-US" sz="1400" dirty="0">
+                      <a:endParaRPr lang="en-US" sz="1250" dirty="0">
                         <a:latin typeface="Calibri" charset="0"/>
                         <a:ea typeface="Calibri" charset="0"/>
                         <a:cs typeface="Calibri" charset="0"/>
@@ -11042,8 +11085,212 @@
                     </a:solidFill>
                   </a:tcPr>
                 </a:tc>
+                <a:tc>
+                  <a:txBody>
+                    <a:bodyPr/>
+                    <a:lstStyle/>
+                    <a:p>
+                      <a:pPr algn="ctr" indent="0" marL="0">
+                        <a:buNone/>
+                      </a:pPr>
+                      <a:r>
+                        <a:rPr lang="en-US" sz="1250" b="1" dirty="0">
+                          <a:solidFill>
+                            <a:srgbClr val="FFFFFF"/>
+                          </a:solidFill>
+                          <a:latin typeface="Calibri" pitchFamily="34" charset="0"/>
+                          <a:ea typeface="Calibri" pitchFamily="34" charset="-122"/>
+                          <a:cs typeface="Calibri" pitchFamily="34" charset="-120"/>
+                        </a:rPr>
+                        <a:t>Short net</a:t>
+                      </a:r>
+                      <a:endParaRPr lang="en-US" sz="1250" dirty="0">
+                        <a:latin typeface="Calibri" charset="0"/>
+                        <a:ea typeface="Calibri" charset="0"/>
+                        <a:cs typeface="Calibri" charset="0"/>
+                      </a:endParaRPr>
+                    </a:p>
+                  </a:txBody>
+                  <a:tcPr marL="91440" marR="91440" marT="45720" marB="45720" anchor="ctr">
+                    <a:lnL w="12700" cap="flat" cmpd="sng" algn="ctr">
+                      <a:solidFill>
+                        <a:srgbClr val="E4E6EE"/>
+                      </a:solidFill>
+                      <a:prstDash val="solid"/>
+                      <a:round/>
+                      <a:headEnd type="none" w="med" len="med"/>
+                      <a:tailEnd type="none" w="med" len="med"/>
+                    </a:lnL>
+                    <a:lnR w="12700" cap="flat" cmpd="sng" algn="ctr">
+                      <a:solidFill>
+                        <a:srgbClr val="E4E6EE"/>
+                      </a:solidFill>
+                      <a:prstDash val="solid"/>
+                      <a:round/>
+                      <a:headEnd type="none" w="med" len="med"/>
+                      <a:tailEnd type="none" w="med" len="med"/>
+                    </a:lnR>
+                    <a:lnT w="12700" cap="flat" cmpd="sng" algn="ctr">
+                      <a:solidFill>
+                        <a:srgbClr val="E4E6EE"/>
+                      </a:solidFill>
+                      <a:prstDash val="solid"/>
+                      <a:round/>
+                      <a:headEnd type="none" w="med" len="med"/>
+                      <a:tailEnd type="none" w="med" len="med"/>
+                    </a:lnT>
+                    <a:lnB w="12700" cap="flat" cmpd="sng" algn="ctr">
+                      <a:solidFill>
+                        <a:srgbClr val="E4E6EE"/>
+                      </a:solidFill>
+                      <a:prstDash val="solid"/>
+                      <a:round/>
+                      <a:headEnd type="none" w="med" len="med"/>
+                      <a:tailEnd type="none" w="med" len="med"/>
+                    </a:lnB>
+                    <a:solidFill>
+                      <a:srgbClr val="1E2761"/>
+                    </a:solidFill>
+                  </a:tcPr>
+                </a:tc>
+                <a:tc>
+                  <a:txBody>
+                    <a:bodyPr/>
+                    <a:lstStyle/>
+                    <a:p>
+                      <a:pPr algn="ctr" indent="0" marL="0">
+                        <a:buNone/>
+                      </a:pPr>
+                      <a:r>
+                        <a:rPr lang="en-US" sz="1250" b="1" dirty="0">
+                          <a:solidFill>
+                            <a:srgbClr val="FFFFFF"/>
+                          </a:solidFill>
+                          <a:latin typeface="Calibri" pitchFamily="34" charset="0"/>
+                          <a:ea typeface="Calibri" pitchFamily="34" charset="-122"/>
+                          <a:cs typeface="Calibri" pitchFamily="34" charset="-120"/>
+                        </a:rPr>
+                        <a:t>Frict</a:t>
+                      </a:r>
+                      <a:endParaRPr lang="en-US" sz="1250" dirty="0">
+                        <a:latin typeface="Calibri" charset="0"/>
+                        <a:ea typeface="Calibri" charset="0"/>
+                        <a:cs typeface="Calibri" charset="0"/>
+                      </a:endParaRPr>
+                    </a:p>
+                  </a:txBody>
+                  <a:tcPr marL="91440" marR="91440" marT="45720" marB="45720" anchor="ctr">
+                    <a:lnL w="12700" cap="flat" cmpd="sng" algn="ctr">
+                      <a:solidFill>
+                        <a:srgbClr val="E4E6EE"/>
+                      </a:solidFill>
+                      <a:prstDash val="solid"/>
+                      <a:round/>
+                      <a:headEnd type="none" w="med" len="med"/>
+                      <a:tailEnd type="none" w="med" len="med"/>
+                    </a:lnL>
+                    <a:lnR w="12700" cap="flat" cmpd="sng" algn="ctr">
+                      <a:solidFill>
+                        <a:srgbClr val="E4E6EE"/>
+                      </a:solidFill>
+                      <a:prstDash val="solid"/>
+                      <a:round/>
+                      <a:headEnd type="none" w="med" len="med"/>
+                      <a:tailEnd type="none" w="med" len="med"/>
+                    </a:lnR>
+                    <a:lnT w="12700" cap="flat" cmpd="sng" algn="ctr">
+                      <a:solidFill>
+                        <a:srgbClr val="E4E6EE"/>
+                      </a:solidFill>
+                      <a:prstDash val="solid"/>
+                      <a:round/>
+                      <a:headEnd type="none" w="med" len="med"/>
+                      <a:tailEnd type="none" w="med" len="med"/>
+                    </a:lnT>
+                    <a:lnB w="12700" cap="flat" cmpd="sng" algn="ctr">
+                      <a:solidFill>
+                        <a:srgbClr val="E4E6EE"/>
+                      </a:solidFill>
+                      <a:prstDash val="solid"/>
+                      <a:round/>
+                      <a:headEnd type="none" w="med" len="med"/>
+                      <a:tailEnd type="none" w="med" len="med"/>
+                    </a:lnB>
+                    <a:solidFill>
+                      <a:srgbClr val="1E2761"/>
+                    </a:solidFill>
+                  </a:tcPr>
+                </a:tc>
+                <a:tc>
+                  <a:txBody>
+                    <a:bodyPr/>
+                    <a:lstStyle/>
+                    <a:p>
+                      <a:pPr algn="ctr" indent="0" marL="0">
+                        <a:buNone/>
+                      </a:pPr>
+                      <a:r>
+                        <a:rPr lang="en-US" sz="1250" b="1" dirty="0">
+                          <a:solidFill>
+                            <a:srgbClr val="FFFFFF"/>
+                          </a:solidFill>
+                          <a:latin typeface="Calibri" pitchFamily="34" charset="0"/>
+                          <a:ea typeface="Calibri" pitchFamily="34" charset="-122"/>
+                          <a:cs typeface="Calibri" pitchFamily="34" charset="-120"/>
+                        </a:rPr>
+                        <a:t>Gross</a:t>
+                      </a:r>
+                      <a:endParaRPr lang="en-US" sz="1250" dirty="0">
+                        <a:latin typeface="Calibri" charset="0"/>
+                        <a:ea typeface="Calibri" charset="0"/>
+                        <a:cs typeface="Calibri" charset="0"/>
+                      </a:endParaRPr>
+                    </a:p>
+                  </a:txBody>
+                  <a:tcPr marL="91440" marR="91440" marT="45720" marB="45720" anchor="ctr">
+                    <a:lnL w="12700" cap="flat" cmpd="sng" algn="ctr">
+                      <a:solidFill>
+                        <a:srgbClr val="E4E6EE"/>
+                      </a:solidFill>
+                      <a:prstDash val="solid"/>
+                      <a:round/>
+                      <a:headEnd type="none" w="med" len="med"/>
+                      <a:tailEnd type="none" w="med" len="med"/>
+                    </a:lnL>
+                    <a:lnR w="12700" cap="flat" cmpd="sng" algn="ctr">
+                      <a:solidFill>
+                        <a:srgbClr val="E4E6EE"/>
+                      </a:solidFill>
+                      <a:prstDash val="solid"/>
+                      <a:round/>
+                      <a:headEnd type="none" w="med" len="med"/>
+                      <a:tailEnd type="none" w="med" len="med"/>
+                    </a:lnR>
+                    <a:lnT w="12700" cap="flat" cmpd="sng" algn="ctr">
+                      <a:solidFill>
+                        <a:srgbClr val="E4E6EE"/>
+                      </a:solidFill>
+                      <a:prstDash val="solid"/>
+                      <a:round/>
+                      <a:headEnd type="none" w="med" len="med"/>
+                      <a:tailEnd type="none" w="med" len="med"/>
+                    </a:lnT>
+                    <a:lnB w="12700" cap="flat" cmpd="sng" algn="ctr">
+                      <a:solidFill>
+                        <a:srgbClr val="E4E6EE"/>
+                      </a:solidFill>
+                      <a:prstDash val="solid"/>
+                      <a:round/>
+                      <a:headEnd type="none" w="med" len="med"/>
+                      <a:tailEnd type="none" w="med" len="med"/>
+                    </a:lnB>
+                    <a:solidFill>
+                      <a:srgbClr val="1E2761"/>
+                    </a:solidFill>
+                  </a:tcPr>
+                </a:tc>
               </a:tr>
-              <a:tr h="566928">
+              <a:tr h="548640">
                 <a:tc>
                   <a:txBody>
                     <a:bodyPr/>
@@ -11053,7 +11300,7 @@
                         <a:buNone/>
                       </a:pPr>
                       <a:r>
-                        <a:rPr lang="en-US" sz="1400" dirty="0">
+                        <a:rPr lang="en-US" sz="1250" dirty="0">
                           <a:solidFill>
                             <a:srgbClr val="27313F"/>
                           </a:solidFill>
@@ -11061,9 +11308,9 @@
                           <a:ea typeface="Calibri" pitchFamily="34" charset="-122"/>
                           <a:cs typeface="Calibri" pitchFamily="34" charset="-120"/>
                         </a:rPr>
-                        <a:t>Long — price appreciation</a:t>
+                        <a:t>BEAR — borrow 30%, 30% short, 150bps</a:t>
                       </a:r>
-                      <a:endParaRPr lang="en-US" sz="1400" dirty="0">
+                      <a:endParaRPr lang="en-US" sz="1250" dirty="0">
                         <a:latin typeface="Calibri" charset="0"/>
                         <a:ea typeface="Calibri" charset="0"/>
                         <a:cs typeface="Calibri" charset="0"/>
@@ -11121,17 +11368,17 @@
                         <a:buNone/>
                       </a:pPr>
                       <a:r>
-                        <a:rPr lang="en-US" sz="1400" b="1" dirty="0">
+                        <a:rPr lang="en-US" sz="1250" dirty="0">
                           <a:solidFill>
-                            <a:srgbClr val="02C39A"/>
+                            <a:srgbClr val="27313F"/>
                           </a:solidFill>
                           <a:latin typeface="Calibri" pitchFamily="34" charset="0"/>
                           <a:ea typeface="Calibri" pitchFamily="34" charset="-122"/>
                           <a:cs typeface="Calibri" pitchFamily="34" charset="-120"/>
                         </a:rPr>
-                        <a:t>+$14.7M</a:t>
+                        <a:t>+$15.2M</a:t>
                       </a:r>
-                      <a:endParaRPr lang="en-US" sz="1400" dirty="0">
+                      <a:endParaRPr lang="en-US" sz="1250" dirty="0">
                         <a:latin typeface="Calibri" charset="0"/>
                         <a:ea typeface="Calibri" charset="0"/>
                         <a:cs typeface="Calibri" charset="0"/>
@@ -11189,7 +11436,7 @@
                         <a:buNone/>
                       </a:pPr>
                       <a:r>
-                        <a:rPr lang="en-US" sz="1400" dirty="0">
+                        <a:rPr lang="en-US" sz="1250" dirty="0">
                           <a:solidFill>
                             <a:srgbClr val="27313F"/>
                           </a:solidFill>
@@ -11197,79 +11444,9 @@
                           <a:ea typeface="Calibri" pitchFamily="34" charset="-122"/>
                           <a:cs typeface="Calibri" pitchFamily="34" charset="-120"/>
                         </a:rPr>
-                        <a:t>95%</a:t>
+                        <a:t>+$0.6M</a:t>
                       </a:r>
-                      <a:endParaRPr lang="en-US" sz="1400" dirty="0">
-                        <a:latin typeface="Calibri" charset="0"/>
-                        <a:ea typeface="Calibri" charset="0"/>
-                        <a:cs typeface="Calibri" charset="0"/>
-                      </a:endParaRPr>
-                    </a:p>
-                  </a:txBody>
-                  <a:tcPr marL="91440" marR="91440" marT="45720" marB="45720" anchor="ctr">
-                    <a:lnL w="12700" cap="flat" cmpd="sng" algn="ctr">
-                      <a:solidFill>
-                        <a:srgbClr val="E4E6EE"/>
-                      </a:solidFill>
-                      <a:prstDash val="solid"/>
-                      <a:round/>
-                      <a:headEnd type="none" w="med" len="med"/>
-                      <a:tailEnd type="none" w="med" len="med"/>
-                    </a:lnL>
-                    <a:lnR w="12700" cap="flat" cmpd="sng" algn="ctr">
-                      <a:solidFill>
-                        <a:srgbClr val="E4E6EE"/>
-                      </a:solidFill>
-                      <a:prstDash val="solid"/>
-                      <a:round/>
-                      <a:headEnd type="none" w="med" len="med"/>
-                      <a:tailEnd type="none" w="med" len="med"/>
-                    </a:lnR>
-                    <a:lnT w="12700" cap="flat" cmpd="sng" algn="ctr">
-                      <a:solidFill>
-                        <a:srgbClr val="E4E6EE"/>
-                      </a:solidFill>
-                      <a:prstDash val="solid"/>
-                      <a:round/>
-                      <a:headEnd type="none" w="med" len="med"/>
-                      <a:tailEnd type="none" w="med" len="med"/>
-                    </a:lnT>
-                    <a:lnB w="12700" cap="flat" cmpd="sng" algn="ctr">
-                      <a:solidFill>
-                        <a:srgbClr val="E4E6EE"/>
-                      </a:solidFill>
-                      <a:prstDash val="solid"/>
-                      <a:round/>
-                      <a:headEnd type="none" w="med" len="med"/>
-                      <a:tailEnd type="none" w="med" len="med"/>
-                    </a:lnB>
-                    <a:solidFill>
-                      <a:srgbClr val="FFFFFF"/>
-                    </a:solidFill>
-                  </a:tcPr>
-                </a:tc>
-              </a:tr>
-              <a:tr h="566928">
-                <a:tc>
-                  <a:txBody>
-                    <a:bodyPr/>
-                    <a:lstStyle/>
-                    <a:p>
-                      <a:pPr algn="l" indent="0" marL="0">
-                        <a:buNone/>
-                      </a:pPr>
-                      <a:r>
-                        <a:rPr lang="en-US" sz="1400" dirty="0">
-                          <a:solidFill>
-                            <a:srgbClr val="27313F"/>
-                          </a:solidFill>
-                          <a:latin typeface="Calibri" pitchFamily="34" charset="0"/>
-                          <a:ea typeface="Calibri" pitchFamily="34" charset="-122"/>
-                          <a:cs typeface="Calibri" pitchFamily="34" charset="-120"/>
-                        </a:rPr>
-                        <a:t>Long — lending income</a:t>
-                      </a:r>
-                      <a:endParaRPr lang="en-US" sz="1400" dirty="0">
+                      <a:endParaRPr lang="en-US" sz="1250" dirty="0">
                         <a:latin typeface="Calibri" charset="0"/>
                         <a:ea typeface="Calibri" charset="0"/>
                         <a:cs typeface="Calibri" charset="0"/>
@@ -11327,17 +11504,17 @@
                         <a:buNone/>
                       </a:pPr>
                       <a:r>
-                        <a:rPr lang="en-US" sz="1400" b="1" dirty="0">
+                        <a:rPr lang="en-US" sz="1250" b="1" dirty="0">
                           <a:solidFill>
-                            <a:srgbClr val="02C39A"/>
+                            <a:srgbClr val="C0392F"/>
                           </a:solidFill>
                           <a:latin typeface="Calibri" pitchFamily="34" charset="0"/>
                           <a:ea typeface="Calibri" pitchFamily="34" charset="-122"/>
                           <a:cs typeface="Calibri" pitchFamily="34" charset="-120"/>
                         </a:rPr>
-                        <a:t>+$4.3M</a:t>
+                        <a:t>−$1.6M</a:t>
                       </a:r>
-                      <a:endParaRPr lang="en-US" sz="1400" dirty="0">
+                      <a:endParaRPr lang="en-US" sz="1250" dirty="0">
                         <a:latin typeface="Calibri" charset="0"/>
                         <a:ea typeface="Calibri" charset="0"/>
                         <a:cs typeface="Calibri" charset="0"/>
@@ -11395,7 +11572,7 @@
                         <a:buNone/>
                       </a:pPr>
                       <a:r>
-                        <a:rPr lang="en-US" sz="1400" dirty="0">
+                        <a:rPr lang="en-US" sz="1250" dirty="0">
                           <a:solidFill>
                             <a:srgbClr val="27313F"/>
                           </a:solidFill>
@@ -11403,79 +11580,9 @@
                           <a:ea typeface="Calibri" pitchFamily="34" charset="-122"/>
                           <a:cs typeface="Calibri" pitchFamily="34" charset="-120"/>
                         </a:rPr>
-                        <a:t>28%</a:t>
+                        <a:t>−$1.8M</a:t>
                       </a:r>
-                      <a:endParaRPr lang="en-US" sz="1400" dirty="0">
-                        <a:latin typeface="Calibri" charset="0"/>
-                        <a:ea typeface="Calibri" charset="0"/>
-                        <a:cs typeface="Calibri" charset="0"/>
-                      </a:endParaRPr>
-                    </a:p>
-                  </a:txBody>
-                  <a:tcPr marL="91440" marR="91440" marT="45720" marB="45720" anchor="ctr">
-                    <a:lnL w="12700" cap="flat" cmpd="sng" algn="ctr">
-                      <a:solidFill>
-                        <a:srgbClr val="E4E6EE"/>
-                      </a:solidFill>
-                      <a:prstDash val="solid"/>
-                      <a:round/>
-                      <a:headEnd type="none" w="med" len="med"/>
-                      <a:tailEnd type="none" w="med" len="med"/>
-                    </a:lnL>
-                    <a:lnR w="12700" cap="flat" cmpd="sng" algn="ctr">
-                      <a:solidFill>
-                        <a:srgbClr val="E4E6EE"/>
-                      </a:solidFill>
-                      <a:prstDash val="solid"/>
-                      <a:round/>
-                      <a:headEnd type="none" w="med" len="med"/>
-                      <a:tailEnd type="none" w="med" len="med"/>
-                    </a:lnR>
-                    <a:lnT w="12700" cap="flat" cmpd="sng" algn="ctr">
-                      <a:solidFill>
-                        <a:srgbClr val="E4E6EE"/>
-                      </a:solidFill>
-                      <a:prstDash val="solid"/>
-                      <a:round/>
-                      <a:headEnd type="none" w="med" len="med"/>
-                      <a:tailEnd type="none" w="med" len="med"/>
-                    </a:lnT>
-                    <a:lnB w="12700" cap="flat" cmpd="sng" algn="ctr">
-                      <a:solidFill>
-                        <a:srgbClr val="E4E6EE"/>
-                      </a:solidFill>
-                      <a:prstDash val="solid"/>
-                      <a:round/>
-                      <a:headEnd type="none" w="med" len="med"/>
-                      <a:tailEnd type="none" w="med" len="med"/>
-                    </a:lnB>
-                    <a:solidFill>
-                      <a:srgbClr val="FFFFFF"/>
-                    </a:solidFill>
-                  </a:tcPr>
-                </a:tc>
-              </a:tr>
-              <a:tr h="566928">
-                <a:tc>
-                  <a:txBody>
-                    <a:bodyPr/>
-                    <a:lstStyle/>
-                    <a:p>
-                      <a:pPr algn="l" indent="0" marL="0">
-                        <a:buNone/>
-                      </a:pPr>
-                      <a:r>
-                        <a:rPr lang="en-US" sz="1400" dirty="0">
-                          <a:solidFill>
-                            <a:srgbClr val="27313F"/>
-                          </a:solidFill>
-                          <a:latin typeface="Calibri" pitchFamily="34" charset="0"/>
-                          <a:ea typeface="Calibri" pitchFamily="34" charset="-122"/>
-                          <a:cs typeface="Calibri" pitchFamily="34" charset="-120"/>
-                        </a:rPr>
-                        <a:t>Short — net (price − borrow cost)</a:t>
-                      </a:r>
-                      <a:endParaRPr lang="en-US" sz="1400" dirty="0">
+                      <a:endParaRPr lang="en-US" sz="1250" dirty="0">
                         <a:latin typeface="Calibri" charset="0"/>
                         <a:ea typeface="Calibri" charset="0"/>
                         <a:cs typeface="Calibri" charset="0"/>
@@ -11533,17 +11640,87 @@
                         <a:buNone/>
                       </a:pPr>
                       <a:r>
-                        <a:rPr lang="en-US" sz="1400" dirty="0">
+                        <a:rPr lang="en-US" sz="1250" dirty="0">
                           <a:solidFill>
-                            <a:srgbClr val="C0392F"/>
+                            <a:srgbClr val="27313F"/>
                           </a:solidFill>
                           <a:latin typeface="Calibri" pitchFamily="34" charset="0"/>
                           <a:ea typeface="Calibri" pitchFamily="34" charset="-122"/>
                           <a:cs typeface="Calibri" pitchFamily="34" charset="-120"/>
                         </a:rPr>
-                        <a:t>−$0.6M</a:t>
+                        <a:t>+$12.3M</a:t>
                       </a:r>
-                      <a:endParaRPr lang="en-US" sz="1400" dirty="0">
+                      <a:endParaRPr lang="en-US" sz="1250" dirty="0">
+                        <a:latin typeface="Calibri" charset="0"/>
+                        <a:ea typeface="Calibri" charset="0"/>
+                        <a:cs typeface="Calibri" charset="0"/>
+                      </a:endParaRPr>
+                    </a:p>
+                  </a:txBody>
+                  <a:tcPr marL="91440" marR="91440" marT="45720" marB="45720" anchor="ctr">
+                    <a:lnL w="12700" cap="flat" cmpd="sng" algn="ctr">
+                      <a:solidFill>
+                        <a:srgbClr val="E4E6EE"/>
+                      </a:solidFill>
+                      <a:prstDash val="solid"/>
+                      <a:round/>
+                      <a:headEnd type="none" w="med" len="med"/>
+                      <a:tailEnd type="none" w="med" len="med"/>
+                    </a:lnL>
+                    <a:lnR w="12700" cap="flat" cmpd="sng" algn="ctr">
+                      <a:solidFill>
+                        <a:srgbClr val="E4E6EE"/>
+                      </a:solidFill>
+                      <a:prstDash val="solid"/>
+                      <a:round/>
+                      <a:headEnd type="none" w="med" len="med"/>
+                      <a:tailEnd type="none" w="med" len="med"/>
+                    </a:lnR>
+                    <a:lnT w="12700" cap="flat" cmpd="sng" algn="ctr">
+                      <a:solidFill>
+                        <a:srgbClr val="E4E6EE"/>
+                      </a:solidFill>
+                      <a:prstDash val="solid"/>
+                      <a:round/>
+                      <a:headEnd type="none" w="med" len="med"/>
+                      <a:tailEnd type="none" w="med" len="med"/>
+                    </a:lnT>
+                    <a:lnB w="12700" cap="flat" cmpd="sng" algn="ctr">
+                      <a:solidFill>
+                        <a:srgbClr val="E4E6EE"/>
+                      </a:solidFill>
+                      <a:prstDash val="solid"/>
+                      <a:round/>
+                      <a:headEnd type="none" w="med" len="med"/>
+                      <a:tailEnd type="none" w="med" len="med"/>
+                    </a:lnB>
+                    <a:solidFill>
+                      <a:srgbClr val="FFFFFF"/>
+                    </a:solidFill>
+                  </a:tcPr>
+                </a:tc>
+              </a:tr>
+              <a:tr h="548640">
+                <a:tc>
+                  <a:txBody>
+                    <a:bodyPr/>
+                    <a:lstStyle/>
+                    <a:p>
+                      <a:pPr algn="l" indent="0" marL="0">
+                        <a:buNone/>
+                      </a:pPr>
+                      <a:r>
+                        <a:rPr lang="en-US" sz="1250" b="1" dirty="0">
+                          <a:solidFill>
+                            <a:srgbClr val="1E2761"/>
+                          </a:solidFill>
+                          <a:latin typeface="Calibri" pitchFamily="34" charset="0"/>
+                          <a:ea typeface="Calibri" pitchFamily="34" charset="-122"/>
+                          <a:cs typeface="Calibri" pitchFamily="34" charset="-120"/>
+                        </a:rPr>
+                        <a:t>BASE — borrow 100%, 60% short, 80bps</a:t>
+                      </a:r>
+                      <a:endParaRPr lang="en-US" sz="1250" dirty="0">
                         <a:latin typeface="Calibri" charset="0"/>
                         <a:ea typeface="Calibri" charset="0"/>
                         <a:cs typeface="Calibri" charset="0"/>
@@ -11601,7 +11778,7 @@
                         <a:buNone/>
                       </a:pPr>
                       <a:r>
-                        <a:rPr lang="en-US" sz="1400" dirty="0">
+                        <a:rPr lang="en-US" sz="1250" dirty="0">
                           <a:solidFill>
                             <a:srgbClr val="27313F"/>
                           </a:solidFill>
@@ -11609,79 +11786,9 @@
                           <a:ea typeface="Calibri" pitchFamily="34" charset="-122"/>
                           <a:cs typeface="Calibri" pitchFamily="34" charset="-120"/>
                         </a:rPr>
-                        <a:t>−4%</a:t>
+                        <a:t>+$14.7M</a:t>
                       </a:r>
-                      <a:endParaRPr lang="en-US" sz="1400" dirty="0">
-                        <a:latin typeface="Calibri" charset="0"/>
-                        <a:ea typeface="Calibri" charset="0"/>
-                        <a:cs typeface="Calibri" charset="0"/>
-                      </a:endParaRPr>
-                    </a:p>
-                  </a:txBody>
-                  <a:tcPr marL="91440" marR="91440" marT="45720" marB="45720" anchor="ctr">
-                    <a:lnL w="12700" cap="flat" cmpd="sng" algn="ctr">
-                      <a:solidFill>
-                        <a:srgbClr val="E4E6EE"/>
-                      </a:solidFill>
-                      <a:prstDash val="solid"/>
-                      <a:round/>
-                      <a:headEnd type="none" w="med" len="med"/>
-                      <a:tailEnd type="none" w="med" len="med"/>
-                    </a:lnL>
-                    <a:lnR w="12700" cap="flat" cmpd="sng" algn="ctr">
-                      <a:solidFill>
-                        <a:srgbClr val="E4E6EE"/>
-                      </a:solidFill>
-                      <a:prstDash val="solid"/>
-                      <a:round/>
-                      <a:headEnd type="none" w="med" len="med"/>
-                      <a:tailEnd type="none" w="med" len="med"/>
-                    </a:lnR>
-                    <a:lnT w="12700" cap="flat" cmpd="sng" algn="ctr">
-                      <a:solidFill>
-                        <a:srgbClr val="E4E6EE"/>
-                      </a:solidFill>
-                      <a:prstDash val="solid"/>
-                      <a:round/>
-                      <a:headEnd type="none" w="med" len="med"/>
-                      <a:tailEnd type="none" w="med" len="med"/>
-                    </a:lnT>
-                    <a:lnB w="12700" cap="flat" cmpd="sng" algn="ctr">
-                      <a:solidFill>
-                        <a:srgbClr val="E4E6EE"/>
-                      </a:solidFill>
-                      <a:prstDash val="solid"/>
-                      <a:round/>
-                      <a:headEnd type="none" w="med" len="med"/>
-                      <a:tailEnd type="none" w="med" len="med"/>
-                    </a:lnB>
-                    <a:solidFill>
-                      <a:srgbClr val="FFFFFF"/>
-                    </a:solidFill>
-                  </a:tcPr>
-                </a:tc>
-              </a:tr>
-              <a:tr h="566928">
-                <a:tc>
-                  <a:txBody>
-                    <a:bodyPr/>
-                    <a:lstStyle/>
-                    <a:p>
-                      <a:pPr algn="l" indent="0" marL="0">
-                        <a:buNone/>
-                      </a:pPr>
-                      <a:r>
-                        <a:rPr lang="en-US" sz="1400" dirty="0">
-                          <a:solidFill>
-                            <a:srgbClr val="27313F"/>
-                          </a:solidFill>
-                          <a:latin typeface="Calibri" pitchFamily="34" charset="0"/>
-                          <a:ea typeface="Calibri" pitchFamily="34" charset="-122"/>
-                          <a:cs typeface="Calibri" pitchFamily="34" charset="-120"/>
-                        </a:rPr>
-                        <a:t>Frictions (impact + commission)</a:t>
-                      </a:r>
-                      <a:endParaRPr lang="en-US" sz="1400" dirty="0">
+                      <a:endParaRPr lang="en-US" sz="1250" dirty="0">
                         <a:latin typeface="Calibri" charset="0"/>
                         <a:ea typeface="Calibri" charset="0"/>
                         <a:cs typeface="Calibri" charset="0"/>
@@ -11739,17 +11846,17 @@
                         <a:buNone/>
                       </a:pPr>
                       <a:r>
-                        <a:rPr lang="en-US" sz="1400" dirty="0">
+                        <a:rPr lang="en-US" sz="1250" dirty="0">
                           <a:solidFill>
-                            <a:srgbClr val="C0392F"/>
+                            <a:srgbClr val="27313F"/>
                           </a:solidFill>
                           <a:latin typeface="Calibri" pitchFamily="34" charset="0"/>
                           <a:ea typeface="Calibri" pitchFamily="34" charset="-122"/>
                           <a:cs typeface="Calibri" pitchFamily="34" charset="-120"/>
                         </a:rPr>
-                        <a:t>−$3.0M</a:t>
+                        <a:t>+$4.3M</a:t>
                       </a:r>
-                      <a:endParaRPr lang="en-US" sz="1400" dirty="0">
+                      <a:endParaRPr lang="en-US" sz="1250" dirty="0">
                         <a:latin typeface="Calibri" charset="0"/>
                         <a:ea typeface="Calibri" charset="0"/>
                         <a:cs typeface="Calibri" charset="0"/>
@@ -11807,87 +11914,17 @@
                         <a:buNone/>
                       </a:pPr>
                       <a:r>
-                        <a:rPr lang="en-US" sz="1400" dirty="0">
+                        <a:rPr lang="en-US" sz="1250" b="1" dirty="0">
                           <a:solidFill>
-                            <a:srgbClr val="27313F"/>
+                            <a:srgbClr val="C0392F"/>
                           </a:solidFill>
                           <a:latin typeface="Calibri" pitchFamily="34" charset="0"/>
                           <a:ea typeface="Calibri" pitchFamily="34" charset="-122"/>
                           <a:cs typeface="Calibri" pitchFamily="34" charset="-120"/>
                         </a:rPr>
-                        <a:t>−20%</a:t>
+                        <a:t>−$0.6M</a:t>
                       </a:r>
-                      <a:endParaRPr lang="en-US" sz="1400" dirty="0">
-                        <a:latin typeface="Calibri" charset="0"/>
-                        <a:ea typeface="Calibri" charset="0"/>
-                        <a:cs typeface="Calibri" charset="0"/>
-                      </a:endParaRPr>
-                    </a:p>
-                  </a:txBody>
-                  <a:tcPr marL="91440" marR="91440" marT="45720" marB="45720" anchor="ctr">
-                    <a:lnL w="12700" cap="flat" cmpd="sng" algn="ctr">
-                      <a:solidFill>
-                        <a:srgbClr val="E4E6EE"/>
-                      </a:solidFill>
-                      <a:prstDash val="solid"/>
-                      <a:round/>
-                      <a:headEnd type="none" w="med" len="med"/>
-                      <a:tailEnd type="none" w="med" len="med"/>
-                    </a:lnL>
-                    <a:lnR w="12700" cap="flat" cmpd="sng" algn="ctr">
-                      <a:solidFill>
-                        <a:srgbClr val="E4E6EE"/>
-                      </a:solidFill>
-                      <a:prstDash val="solid"/>
-                      <a:round/>
-                      <a:headEnd type="none" w="med" len="med"/>
-                      <a:tailEnd type="none" w="med" len="med"/>
-                    </a:lnR>
-                    <a:lnT w="12700" cap="flat" cmpd="sng" algn="ctr">
-                      <a:solidFill>
-                        <a:srgbClr val="E4E6EE"/>
-                      </a:solidFill>
-                      <a:prstDash val="solid"/>
-                      <a:round/>
-                      <a:headEnd type="none" w="med" len="med"/>
-                      <a:tailEnd type="none" w="med" len="med"/>
-                    </a:lnT>
-                    <a:lnB w="12700" cap="flat" cmpd="sng" algn="ctr">
-                      <a:solidFill>
-                        <a:srgbClr val="E4E6EE"/>
-                      </a:solidFill>
-                      <a:prstDash val="solid"/>
-                      <a:round/>
-                      <a:headEnd type="none" w="med" len="med"/>
-                      <a:tailEnd type="none" w="med" len="med"/>
-                    </a:lnB>
-                    <a:solidFill>
-                      <a:srgbClr val="FFFFFF"/>
-                    </a:solidFill>
-                  </a:tcPr>
-                </a:tc>
-              </a:tr>
-              <a:tr h="566928">
-                <a:tc>
-                  <a:txBody>
-                    <a:bodyPr/>
-                    <a:lstStyle/>
-                    <a:p>
-                      <a:pPr algn="l" indent="0" marL="0">
-                        <a:buNone/>
-                      </a:pPr>
-                      <a:r>
-                        <a:rPr lang="en-US" sz="1400" b="1" dirty="0">
-                          <a:solidFill>
-                            <a:srgbClr val="1E2761"/>
-                          </a:solidFill>
-                          <a:latin typeface="Calibri" pitchFamily="34" charset="0"/>
-                          <a:ea typeface="Calibri" pitchFamily="34" charset="-122"/>
-                          <a:cs typeface="Calibri" pitchFamily="34" charset="-120"/>
-                        </a:rPr>
-                        <a:t>Gross</a:t>
-                      </a:r>
-                      <a:endParaRPr lang="en-US" sz="1400" dirty="0">
+                      <a:endParaRPr lang="en-US" sz="1250" dirty="0">
                         <a:latin typeface="Calibri" charset="0"/>
                         <a:ea typeface="Calibri" charset="0"/>
                         <a:cs typeface="Calibri" charset="0"/>
@@ -11945,17 +11982,17 @@
                         <a:buNone/>
                       </a:pPr>
                       <a:r>
-                        <a:rPr lang="en-US" sz="1400" b="1" dirty="0">
+                        <a:rPr lang="en-US" sz="1250" dirty="0">
                           <a:solidFill>
-                            <a:srgbClr val="1E2761"/>
+                            <a:srgbClr val="27313F"/>
                           </a:solidFill>
                           <a:latin typeface="Calibri" pitchFamily="34" charset="0"/>
                           <a:ea typeface="Calibri" pitchFamily="34" charset="-122"/>
                           <a:cs typeface="Calibri" pitchFamily="34" charset="-120"/>
                         </a:rPr>
-                        <a:t>≈ $15.4M</a:t>
+                        <a:t>−$1.1M</a:t>
                       </a:r>
-                      <a:endParaRPr lang="en-US" sz="1400" dirty="0">
+                      <a:endParaRPr lang="en-US" sz="1250" dirty="0">
                         <a:latin typeface="Calibri" charset="0"/>
                         <a:ea typeface="Calibri" charset="0"/>
                         <a:cs typeface="Calibri" charset="0"/>
@@ -12013,17 +12050,427 @@
                         <a:buNone/>
                       </a:pPr>
                       <a:r>
-                        <a:rPr lang="en-US" sz="1400" b="1" dirty="0">
+                        <a:rPr lang="en-US" sz="1250" b="1" dirty="0">
                           <a:solidFill>
-                            <a:srgbClr val="1E2761"/>
+                            <a:srgbClr val="27313F"/>
                           </a:solidFill>
                           <a:latin typeface="Calibri" pitchFamily="34" charset="0"/>
                           <a:ea typeface="Calibri" pitchFamily="34" charset="-122"/>
                           <a:cs typeface="Calibri" pitchFamily="34" charset="-120"/>
                         </a:rPr>
-                        <a:t>100%</a:t>
+                        <a:t>+$17.3M</a:t>
                       </a:r>
-                      <a:endParaRPr lang="en-US" sz="1400" dirty="0">
+                      <a:endParaRPr lang="en-US" sz="1250" dirty="0">
+                        <a:latin typeface="Calibri" charset="0"/>
+                        <a:ea typeface="Calibri" charset="0"/>
+                        <a:cs typeface="Calibri" charset="0"/>
+                      </a:endParaRPr>
+                    </a:p>
+                  </a:txBody>
+                  <a:tcPr marL="91440" marR="91440" marT="45720" marB="45720" anchor="ctr">
+                    <a:lnL w="12700" cap="flat" cmpd="sng" algn="ctr">
+                      <a:solidFill>
+                        <a:srgbClr val="E4E6EE"/>
+                      </a:solidFill>
+                      <a:prstDash val="solid"/>
+                      <a:round/>
+                      <a:headEnd type="none" w="med" len="med"/>
+                      <a:tailEnd type="none" w="med" len="med"/>
+                    </a:lnL>
+                    <a:lnR w="12700" cap="flat" cmpd="sng" algn="ctr">
+                      <a:solidFill>
+                        <a:srgbClr val="E4E6EE"/>
+                      </a:solidFill>
+                      <a:prstDash val="solid"/>
+                      <a:round/>
+                      <a:headEnd type="none" w="med" len="med"/>
+                      <a:tailEnd type="none" w="med" len="med"/>
+                    </a:lnR>
+                    <a:lnT w="12700" cap="flat" cmpd="sng" algn="ctr">
+                      <a:solidFill>
+                        <a:srgbClr val="E4E6EE"/>
+                      </a:solidFill>
+                      <a:prstDash val="solid"/>
+                      <a:round/>
+                      <a:headEnd type="none" w="med" len="med"/>
+                      <a:tailEnd type="none" w="med" len="med"/>
+                    </a:lnT>
+                    <a:lnB w="12700" cap="flat" cmpd="sng" algn="ctr">
+                      <a:solidFill>
+                        <a:srgbClr val="E4E6EE"/>
+                      </a:solidFill>
+                      <a:prstDash val="solid"/>
+                      <a:round/>
+                      <a:headEnd type="none" w="med" len="med"/>
+                      <a:tailEnd type="none" w="med" len="med"/>
+                    </a:lnB>
+                    <a:solidFill>
+                      <a:srgbClr val="FFFFFF"/>
+                    </a:solidFill>
+                  </a:tcPr>
+                </a:tc>
+              </a:tr>
+              <a:tr h="548640">
+                <a:tc>
+                  <a:txBody>
+                    <a:bodyPr/>
+                    <a:lstStyle/>
+                    <a:p>
+                      <a:pPr algn="l" indent="0" marL="0">
+                        <a:buNone/>
+                      </a:pPr>
+                      <a:r>
+                        <a:rPr lang="en-US" sz="1250" dirty="0">
+                          <a:solidFill>
+                            <a:srgbClr val="27313F"/>
+                          </a:solidFill>
+                          <a:latin typeface="Calibri" pitchFamily="34" charset="0"/>
+                          <a:ea typeface="Calibri" pitchFamily="34" charset="-122"/>
+                          <a:cs typeface="Calibri" pitchFamily="34" charset="-120"/>
+                        </a:rPr>
+                        <a:t>BULL — borrow 200%, 70% short, 50bps</a:t>
+                      </a:r>
+                      <a:endParaRPr lang="en-US" sz="1250" dirty="0">
+                        <a:latin typeface="Calibri" charset="0"/>
+                        <a:ea typeface="Calibri" charset="0"/>
+                        <a:cs typeface="Calibri" charset="0"/>
+                      </a:endParaRPr>
+                    </a:p>
+                  </a:txBody>
+                  <a:tcPr marL="91440" marR="91440" marT="45720" marB="45720" anchor="ctr">
+                    <a:lnL w="12700" cap="flat" cmpd="sng" algn="ctr">
+                      <a:solidFill>
+                        <a:srgbClr val="E4E6EE"/>
+                      </a:solidFill>
+                      <a:prstDash val="solid"/>
+                      <a:round/>
+                      <a:headEnd type="none" w="med" len="med"/>
+                      <a:tailEnd type="none" w="med" len="med"/>
+                    </a:lnL>
+                    <a:lnR w="12700" cap="flat" cmpd="sng" algn="ctr">
+                      <a:solidFill>
+                        <a:srgbClr val="E4E6EE"/>
+                      </a:solidFill>
+                      <a:prstDash val="solid"/>
+                      <a:round/>
+                      <a:headEnd type="none" w="med" len="med"/>
+                      <a:tailEnd type="none" w="med" len="med"/>
+                    </a:lnR>
+                    <a:lnT w="12700" cap="flat" cmpd="sng" algn="ctr">
+                      <a:solidFill>
+                        <a:srgbClr val="E4E6EE"/>
+                      </a:solidFill>
+                      <a:prstDash val="solid"/>
+                      <a:round/>
+                      <a:headEnd type="none" w="med" len="med"/>
+                      <a:tailEnd type="none" w="med" len="med"/>
+                    </a:lnT>
+                    <a:lnB w="12700" cap="flat" cmpd="sng" algn="ctr">
+                      <a:solidFill>
+                        <a:srgbClr val="E4E6EE"/>
+                      </a:solidFill>
+                      <a:prstDash val="solid"/>
+                      <a:round/>
+                      <a:headEnd type="none" w="med" len="med"/>
+                      <a:tailEnd type="none" w="med" len="med"/>
+                    </a:lnB>
+                    <a:solidFill>
+                      <a:srgbClr val="FFFFFF"/>
+                    </a:solidFill>
+                  </a:tcPr>
+                </a:tc>
+                <a:tc>
+                  <a:txBody>
+                    <a:bodyPr/>
+                    <a:lstStyle/>
+                    <a:p>
+                      <a:pPr algn="ctr" indent="0" marL="0">
+                        <a:buNone/>
+                      </a:pPr>
+                      <a:r>
+                        <a:rPr lang="en-US" sz="1250" dirty="0">
+                          <a:solidFill>
+                            <a:srgbClr val="27313F"/>
+                          </a:solidFill>
+                          <a:latin typeface="Calibri" pitchFamily="34" charset="0"/>
+                          <a:ea typeface="Calibri" pitchFamily="34" charset="-122"/>
+                          <a:cs typeface="Calibri" pitchFamily="34" charset="-120"/>
+                        </a:rPr>
+                        <a:t>+$14.7M</a:t>
+                      </a:r>
+                      <a:endParaRPr lang="en-US" sz="1250" dirty="0">
+                        <a:latin typeface="Calibri" charset="0"/>
+                        <a:ea typeface="Calibri" charset="0"/>
+                        <a:cs typeface="Calibri" charset="0"/>
+                      </a:endParaRPr>
+                    </a:p>
+                  </a:txBody>
+                  <a:tcPr marL="91440" marR="91440" marT="45720" marB="45720" anchor="ctr">
+                    <a:lnL w="12700" cap="flat" cmpd="sng" algn="ctr">
+                      <a:solidFill>
+                        <a:srgbClr val="E4E6EE"/>
+                      </a:solidFill>
+                      <a:prstDash val="solid"/>
+                      <a:round/>
+                      <a:headEnd type="none" w="med" len="med"/>
+                      <a:tailEnd type="none" w="med" len="med"/>
+                    </a:lnL>
+                    <a:lnR w="12700" cap="flat" cmpd="sng" algn="ctr">
+                      <a:solidFill>
+                        <a:srgbClr val="E4E6EE"/>
+                      </a:solidFill>
+                      <a:prstDash val="solid"/>
+                      <a:round/>
+                      <a:headEnd type="none" w="med" len="med"/>
+                      <a:tailEnd type="none" w="med" len="med"/>
+                    </a:lnR>
+                    <a:lnT w="12700" cap="flat" cmpd="sng" algn="ctr">
+                      <a:solidFill>
+                        <a:srgbClr val="E4E6EE"/>
+                      </a:solidFill>
+                      <a:prstDash val="solid"/>
+                      <a:round/>
+                      <a:headEnd type="none" w="med" len="med"/>
+                      <a:tailEnd type="none" w="med" len="med"/>
+                    </a:lnT>
+                    <a:lnB w="12700" cap="flat" cmpd="sng" algn="ctr">
+                      <a:solidFill>
+                        <a:srgbClr val="E4E6EE"/>
+                      </a:solidFill>
+                      <a:prstDash val="solid"/>
+                      <a:round/>
+                      <a:headEnd type="none" w="med" len="med"/>
+                      <a:tailEnd type="none" w="med" len="med"/>
+                    </a:lnB>
+                    <a:solidFill>
+                      <a:srgbClr val="FFFFFF"/>
+                    </a:solidFill>
+                  </a:tcPr>
+                </a:tc>
+                <a:tc>
+                  <a:txBody>
+                    <a:bodyPr/>
+                    <a:lstStyle/>
+                    <a:p>
+                      <a:pPr algn="ctr" indent="0" marL="0">
+                        <a:buNone/>
+                      </a:pPr>
+                      <a:r>
+                        <a:rPr lang="en-US" sz="1250" dirty="0">
+                          <a:solidFill>
+                            <a:srgbClr val="27313F"/>
+                          </a:solidFill>
+                          <a:latin typeface="Calibri" pitchFamily="34" charset="0"/>
+                          <a:ea typeface="Calibri" pitchFamily="34" charset="-122"/>
+                          <a:cs typeface="Calibri" pitchFamily="34" charset="-120"/>
+                        </a:rPr>
+                        <a:t>+$17.4M</a:t>
+                      </a:r>
+                      <a:endParaRPr lang="en-US" sz="1250" dirty="0">
+                        <a:latin typeface="Calibri" charset="0"/>
+                        <a:ea typeface="Calibri" charset="0"/>
+                        <a:cs typeface="Calibri" charset="0"/>
+                      </a:endParaRPr>
+                    </a:p>
+                  </a:txBody>
+                  <a:tcPr marL="91440" marR="91440" marT="45720" marB="45720" anchor="ctr">
+                    <a:lnL w="12700" cap="flat" cmpd="sng" algn="ctr">
+                      <a:solidFill>
+                        <a:srgbClr val="E4E6EE"/>
+                      </a:solidFill>
+                      <a:prstDash val="solid"/>
+                      <a:round/>
+                      <a:headEnd type="none" w="med" len="med"/>
+                      <a:tailEnd type="none" w="med" len="med"/>
+                    </a:lnL>
+                    <a:lnR w="12700" cap="flat" cmpd="sng" algn="ctr">
+                      <a:solidFill>
+                        <a:srgbClr val="E4E6EE"/>
+                      </a:solidFill>
+                      <a:prstDash val="solid"/>
+                      <a:round/>
+                      <a:headEnd type="none" w="med" len="med"/>
+                      <a:tailEnd type="none" w="med" len="med"/>
+                    </a:lnR>
+                    <a:lnT w="12700" cap="flat" cmpd="sng" algn="ctr">
+                      <a:solidFill>
+                        <a:srgbClr val="E4E6EE"/>
+                      </a:solidFill>
+                      <a:prstDash val="solid"/>
+                      <a:round/>
+                      <a:headEnd type="none" w="med" len="med"/>
+                      <a:tailEnd type="none" w="med" len="med"/>
+                    </a:lnT>
+                    <a:lnB w="12700" cap="flat" cmpd="sng" algn="ctr">
+                      <a:solidFill>
+                        <a:srgbClr val="E4E6EE"/>
+                      </a:solidFill>
+                      <a:prstDash val="solid"/>
+                      <a:round/>
+                      <a:headEnd type="none" w="med" len="med"/>
+                      <a:tailEnd type="none" w="med" len="med"/>
+                    </a:lnB>
+                    <a:solidFill>
+                      <a:srgbClr val="FFFFFF"/>
+                    </a:solidFill>
+                  </a:tcPr>
+                </a:tc>
+                <a:tc>
+                  <a:txBody>
+                    <a:bodyPr/>
+                    <a:lstStyle/>
+                    <a:p>
+                      <a:pPr algn="ctr" indent="0" marL="0">
+                        <a:buNone/>
+                      </a:pPr>
+                      <a:r>
+                        <a:rPr lang="en-US" sz="1250" b="1" dirty="0">
+                          <a:solidFill>
+                            <a:srgbClr val="02C39A"/>
+                          </a:solidFill>
+                          <a:latin typeface="Calibri" pitchFamily="34" charset="0"/>
+                          <a:ea typeface="Calibri" pitchFamily="34" charset="-122"/>
+                          <a:cs typeface="Calibri" pitchFamily="34" charset="-120"/>
+                        </a:rPr>
+                        <a:t>+$0.1M</a:t>
+                      </a:r>
+                      <a:endParaRPr lang="en-US" sz="1250" dirty="0">
+                        <a:latin typeface="Calibri" charset="0"/>
+                        <a:ea typeface="Calibri" charset="0"/>
+                        <a:cs typeface="Calibri" charset="0"/>
+                      </a:endParaRPr>
+                    </a:p>
+                  </a:txBody>
+                  <a:tcPr marL="91440" marR="91440" marT="45720" marB="45720" anchor="ctr">
+                    <a:lnL w="12700" cap="flat" cmpd="sng" algn="ctr">
+                      <a:solidFill>
+                        <a:srgbClr val="E4E6EE"/>
+                      </a:solidFill>
+                      <a:prstDash val="solid"/>
+                      <a:round/>
+                      <a:headEnd type="none" w="med" len="med"/>
+                      <a:tailEnd type="none" w="med" len="med"/>
+                    </a:lnL>
+                    <a:lnR w="12700" cap="flat" cmpd="sng" algn="ctr">
+                      <a:solidFill>
+                        <a:srgbClr val="E4E6EE"/>
+                      </a:solidFill>
+                      <a:prstDash val="solid"/>
+                      <a:round/>
+                      <a:headEnd type="none" w="med" len="med"/>
+                      <a:tailEnd type="none" w="med" len="med"/>
+                    </a:lnR>
+                    <a:lnT w="12700" cap="flat" cmpd="sng" algn="ctr">
+                      <a:solidFill>
+                        <a:srgbClr val="E4E6EE"/>
+                      </a:solidFill>
+                      <a:prstDash val="solid"/>
+                      <a:round/>
+                      <a:headEnd type="none" w="med" len="med"/>
+                      <a:tailEnd type="none" w="med" len="med"/>
+                    </a:lnT>
+                    <a:lnB w="12700" cap="flat" cmpd="sng" algn="ctr">
+                      <a:solidFill>
+                        <a:srgbClr val="E4E6EE"/>
+                      </a:solidFill>
+                      <a:prstDash val="solid"/>
+                      <a:round/>
+                      <a:headEnd type="none" w="med" len="med"/>
+                      <a:tailEnd type="none" w="med" len="med"/>
+                    </a:lnB>
+                    <a:solidFill>
+                      <a:srgbClr val="FFFFFF"/>
+                    </a:solidFill>
+                  </a:tcPr>
+                </a:tc>
+                <a:tc>
+                  <a:txBody>
+                    <a:bodyPr/>
+                    <a:lstStyle/>
+                    <a:p>
+                      <a:pPr algn="ctr" indent="0" marL="0">
+                        <a:buNone/>
+                      </a:pPr>
+                      <a:r>
+                        <a:rPr lang="en-US" sz="1250" dirty="0">
+                          <a:solidFill>
+                            <a:srgbClr val="27313F"/>
+                          </a:solidFill>
+                          <a:latin typeface="Calibri" pitchFamily="34" charset="0"/>
+                          <a:ea typeface="Calibri" pitchFamily="34" charset="-122"/>
+                          <a:cs typeface="Calibri" pitchFamily="34" charset="-120"/>
+                        </a:rPr>
+                        <a:t>−$0.8M</a:t>
+                      </a:r>
+                      <a:endParaRPr lang="en-US" sz="1250" dirty="0">
+                        <a:latin typeface="Calibri" charset="0"/>
+                        <a:ea typeface="Calibri" charset="0"/>
+                        <a:cs typeface="Calibri" charset="0"/>
+                      </a:endParaRPr>
+                    </a:p>
+                  </a:txBody>
+                  <a:tcPr marL="91440" marR="91440" marT="45720" marB="45720" anchor="ctr">
+                    <a:lnL w="12700" cap="flat" cmpd="sng" algn="ctr">
+                      <a:solidFill>
+                        <a:srgbClr val="E4E6EE"/>
+                      </a:solidFill>
+                      <a:prstDash val="solid"/>
+                      <a:round/>
+                      <a:headEnd type="none" w="med" len="med"/>
+                      <a:tailEnd type="none" w="med" len="med"/>
+                    </a:lnL>
+                    <a:lnR w="12700" cap="flat" cmpd="sng" algn="ctr">
+                      <a:solidFill>
+                        <a:srgbClr val="E4E6EE"/>
+                      </a:solidFill>
+                      <a:prstDash val="solid"/>
+                      <a:round/>
+                      <a:headEnd type="none" w="med" len="med"/>
+                      <a:tailEnd type="none" w="med" len="med"/>
+                    </a:lnR>
+                    <a:lnT w="12700" cap="flat" cmpd="sng" algn="ctr">
+                      <a:solidFill>
+                        <a:srgbClr val="E4E6EE"/>
+                      </a:solidFill>
+                      <a:prstDash val="solid"/>
+                      <a:round/>
+                      <a:headEnd type="none" w="med" len="med"/>
+                      <a:tailEnd type="none" w="med" len="med"/>
+                    </a:lnT>
+                    <a:lnB w="12700" cap="flat" cmpd="sng" algn="ctr">
+                      <a:solidFill>
+                        <a:srgbClr val="E4E6EE"/>
+                      </a:solidFill>
+                      <a:prstDash val="solid"/>
+                      <a:round/>
+                      <a:headEnd type="none" w="med" len="med"/>
+                      <a:tailEnd type="none" w="med" len="med"/>
+                    </a:lnB>
+                    <a:solidFill>
+                      <a:srgbClr val="FFFFFF"/>
+                    </a:solidFill>
+                  </a:tcPr>
+                </a:tc>
+                <a:tc>
+                  <a:txBody>
+                    <a:bodyPr/>
+                    <a:lstStyle/>
+                    <a:p>
+                      <a:pPr algn="ctr" indent="0" marL="0">
+                        <a:buNone/>
+                      </a:pPr>
+                      <a:r>
+                        <a:rPr lang="en-US" sz="1250" dirty="0">
+                          <a:solidFill>
+                            <a:srgbClr val="27313F"/>
+                          </a:solidFill>
+                          <a:latin typeface="Calibri" pitchFamily="34" charset="0"/>
+                          <a:ea typeface="Calibri" pitchFamily="34" charset="-122"/>
+                          <a:cs typeface="Calibri" pitchFamily="34" charset="-120"/>
+                        </a:rPr>
+                        <a:t>+$31.5M</a:t>
+                      </a:r>
+                      <a:endParaRPr lang="en-US" sz="1250" dirty="0">
                         <a:latin typeface="Calibri" charset="0"/>
                         <a:ea typeface="Calibri" charset="0"/>
                         <a:cs typeface="Calibri" charset="0"/>
@@ -12085,12 +12532,98 @@
         </p:nvSpPr>
         <p:spPr>
           <a:xfrm>
-            <a:off x="7543800" y="1600200"/>
-            <a:ext cx="4069080" cy="1600200"/>
+            <a:off x="548640" y="3840480"/>
+            <a:ext cx="5486400" cy="1234440"/>
           </a:xfrm>
           <a:prstGeom prst="roundRect">
             <a:avLst>
-              <a:gd name="adj" fmla="val 5143"/>
+              <a:gd name="adj" fmla="val 6667"/>
+            </a:avLst>
+          </a:prstGeom>
+          <a:solidFill>
+            <a:srgbClr val="FBF3F2"/>
+          </a:solidFill>
+          <a:ln w="12700">
+            <a:solidFill>
+              <a:srgbClr val="C0392F"/>
+            </a:solidFill>
+            <a:prstDash val="solid"/>
+          </a:ln>
+        </p:spPr>
+      </p:sp>
+      <p:sp>
+        <p:nvSpPr>
+          <p:cNvPr id="7" name="Text 4"/>
+          <p:cNvSpPr/>
+          <p:nvPr/>
+        </p:nvSpPr>
+        <p:spPr>
+          <a:xfrm>
+            <a:off x="777240" y="3950208"/>
+            <a:ext cx="5029200" cy="1051560"/>
+          </a:xfrm>
+          <a:prstGeom prst="rect">
+            <a:avLst/>
+          </a:prstGeom>
+          <a:noFill/>
+          <a:ln/>
+        </p:spPr>
+        <p:txBody>
+          <a:bodyPr wrap="square" lIns="0" tIns="0" rIns="0" bIns="0" rtlCol="0" anchor="ctr"/>
+          <a:lstStyle/>
+          <a:p>
+            <a:pPr indent="0" marL="0">
+              <a:lnSpc>
+                <a:spcPct val="110000"/>
+              </a:lnSpc>
+              <a:buNone/>
+            </a:pPr>
+            <a:r>
+              <a:rPr lang="en-US" sz="1200" b="1" dirty="0">
+                <a:solidFill>
+                  <a:srgbClr val="C0392F"/>
+                </a:solidFill>
+                <a:latin typeface="Calibri" pitchFamily="34" charset="0"/>
+                <a:ea typeface="Calibri" pitchFamily="34" charset="-122"/>
+                <a:cs typeface="Calibri" pitchFamily="34" charset="-120"/>
+              </a:rPr>
+              <a:t>Short is negative except in BULL.  </a:t>
+            </a:r>
+            <a:pPr indent="0" marL="0">
+              <a:lnSpc>
+                <a:spcPct val="110000"/>
+              </a:lnSpc>
+              <a:buNone/>
+            </a:pPr>
+            <a:r>
+              <a:rPr lang="en-US" sz="1200" dirty="0">
+                <a:solidFill>
+                  <a:srgbClr val="27313F"/>
+                </a:solidFill>
+                <a:latin typeface="Calibri" pitchFamily="34" charset="0"/>
+                <a:ea typeface="Calibri" pitchFamily="34" charset="-122"/>
+                <a:cs typeface="Calibri" pitchFamily="34" charset="-120"/>
+              </a:rPr>
+              <a:t>Of 103 failures we can borrow only ~60% (62) — the biggest drops are un-borrowable — so what's left barely covers borrow cost. Loses in BEAR/BASE; dropped.</a:t>
+            </a:r>
+            <a:endParaRPr lang="en-US" sz="1200" dirty="0"/>
+          </a:p>
+        </p:txBody>
+      </p:sp>
+      <p:sp>
+        <p:nvSpPr>
+          <p:cNvPr id="8" name="Shape 5"/>
+          <p:cNvSpPr/>
+          <p:nvPr/>
+        </p:nvSpPr>
+        <p:spPr>
+          <a:xfrm>
+            <a:off x="6263640" y="3840480"/>
+            <a:ext cx="5349240" cy="1234440"/>
+          </a:xfrm>
+          <a:prstGeom prst="roundRect">
+            <a:avLst>
+              <a:gd name="adj" fmla="val 6667"/>
             </a:avLst>
           </a:prstGeom>
           <a:solidFill>
@@ -12106,14 +12639,14 @@
       </p:sp>
       <p:sp>
         <p:nvSpPr>
-          <p:cNvPr id="7" name="Text 4"/>
+          <p:cNvPr id="9" name="Text 6"/>
           <p:cNvSpPr/>
           <p:nvPr/>
         </p:nvSpPr>
         <p:spPr>
           <a:xfrm>
-            <a:off x="7726680" y="1737360"/>
-            <a:ext cx="3657600" cy="640080"/>
+            <a:off x="6492240" y="3977640"/>
+            <a:ext cx="4892040" cy="1005840"/>
           </a:xfrm>
           <a:prstGeom prst="rect">
             <a:avLst/>
@@ -12126,154 +12659,30 @@
           <a:lstStyle/>
           <a:p>
             <a:pPr indent="0" marL="0">
-              <a:buNone/>
-            </a:pPr>
-            <a:r>
-              <a:rPr lang="en-US" sz="3400" b="1" dirty="0">
+              <a:lnSpc>
+                <a:spcPct val="112000"/>
+              </a:lnSpc>
+              <a:buNone/>
+            </a:pPr>
+            <a:r>
+              <a:rPr lang="en-US" sz="1250" b="1" dirty="0">
                 <a:solidFill>
                   <a:srgbClr val="02C39A"/>
-                </a:solidFill>
-                <a:latin typeface="Cambria" pitchFamily="34" charset="0"/>
-                <a:ea typeface="Cambria" pitchFamily="34" charset="-122"/>
-                <a:cs typeface="Cambria" pitchFamily="34" charset="-120"/>
-              </a:rPr>
-              <a:t>~92%</a:t>
-            </a:r>
-            <a:endParaRPr lang="en-US" sz="3400" dirty="0"/>
-          </a:p>
-        </p:txBody>
-      </p:sp>
-      <p:sp>
-        <p:nvSpPr>
-          <p:cNvPr id="8" name="Text 5"/>
-          <p:cNvSpPr/>
-          <p:nvPr/>
-        </p:nvSpPr>
-        <p:spPr>
-          <a:xfrm>
-            <a:off x="7726680" y="2377440"/>
-            <a:ext cx="3703320" cy="731520"/>
-          </a:xfrm>
-          <a:prstGeom prst="rect">
-            <a:avLst/>
-          </a:prstGeom>
-          <a:noFill/>
-          <a:ln/>
-        </p:spPr>
-        <p:txBody>
-          <a:bodyPr wrap="square" lIns="0" tIns="0" rIns="0" bIns="0" rtlCol="0" anchor="t"/>
-          <a:lstStyle/>
-          <a:p>
-            <a:pPr indent="0" marL="0">
-              <a:buNone/>
-            </a:pPr>
-            <a:r>
-              <a:rPr lang="en-US" sz="1300" dirty="0">
-                <a:solidFill>
-                  <a:srgbClr val="27313F"/>
                 </a:solidFill>
                 <a:latin typeface="Calibri" pitchFamily="34" charset="0"/>
                 <a:ea typeface="Calibri" pitchFamily="34" charset="-122"/>
                 <a:cs typeface="Calibri" pitchFamily="34" charset="-120"/>
               </a:rPr>
-              <a:t>of gross comes from long-and-lend. The short book is a hedge, not a profit center.</a:t>
-            </a:r>
-            <a:endParaRPr lang="en-US" sz="1300" dirty="0"/>
-          </a:p>
-        </p:txBody>
-      </p:sp>
-      <p:sp>
-        <p:nvSpPr>
-          <p:cNvPr id="9" name="Shape 6"/>
-          <p:cNvSpPr/>
-          <p:nvPr/>
-        </p:nvSpPr>
-        <p:spPr>
-          <a:xfrm>
-            <a:off x="7543800" y="3383280"/>
-            <a:ext cx="4069080" cy="1600200"/>
-          </a:xfrm>
-          <a:prstGeom prst="roundRect">
-            <a:avLst>
-              <a:gd name="adj" fmla="val 5143"/>
-            </a:avLst>
-          </a:prstGeom>
-          <a:solidFill>
-            <a:srgbClr val="F4F6FC"/>
-          </a:solidFill>
-          <a:ln w="12700">
-            <a:solidFill>
-              <a:srgbClr val="E4E6EE"/>
-            </a:solidFill>
-            <a:prstDash val="solid"/>
-          </a:ln>
-        </p:spPr>
-      </p:sp>
-      <p:sp>
-        <p:nvSpPr>
-          <p:cNvPr id="10" name="Text 7"/>
-          <p:cNvSpPr/>
-          <p:nvPr/>
-        </p:nvSpPr>
-        <p:spPr>
-          <a:xfrm>
-            <a:off x="7726680" y="3520440"/>
-            <a:ext cx="3657600" cy="640080"/>
-          </a:xfrm>
-          <a:prstGeom prst="rect">
-            <a:avLst/>
-          </a:prstGeom>
-          <a:noFill/>
-          <a:ln/>
-        </p:spPr>
-        <p:txBody>
-          <a:bodyPr wrap="square" lIns="0" tIns="0" rIns="0" bIns="0" rtlCol="0" anchor="ctr"/>
-          <a:lstStyle/>
-          <a:p>
+              <a:t>Lending is the swing factor.  </a:t>
+            </a:r>
             <a:pPr indent="0" marL="0">
-              <a:buNone/>
-            </a:pPr>
-            <a:r>
-              <a:rPr lang="en-US" sz="3400" b="1" dirty="0">
-                <a:solidFill>
-                  <a:srgbClr val="1E2761"/>
-                </a:solidFill>
-                <a:latin typeface="Cambria" pitchFamily="34" charset="0"/>
-                <a:ea typeface="Cambria" pitchFamily="34" charset="-122"/>
-                <a:cs typeface="Cambria" pitchFamily="34" charset="-120"/>
-              </a:rPr>
-              <a:t>+19%</a:t>
-            </a:r>
-            <a:endParaRPr lang="en-US" sz="3400" dirty="0"/>
-          </a:p>
-        </p:txBody>
-      </p:sp>
-      <p:sp>
-        <p:nvSpPr>
-          <p:cNvPr id="11" name="Text 8"/>
-          <p:cNvSpPr/>
-          <p:nvPr/>
-        </p:nvSpPr>
-        <p:spPr>
-          <a:xfrm>
-            <a:off x="7726680" y="4160520"/>
-            <a:ext cx="3703320" cy="731520"/>
-          </a:xfrm>
-          <a:prstGeom prst="rect">
-            <a:avLst/>
-          </a:prstGeom>
-          <a:noFill/>
-          <a:ln/>
-        </p:spPr>
-        <p:txBody>
-          <a:bodyPr wrap="square" lIns="0" tIns="0" rIns="0" bIns="0" rtlCol="0" anchor="t"/>
-          <a:lstStyle/>
-          <a:p>
-            <a:pPr indent="0" marL="0">
-              <a:buNone/>
-            </a:pPr>
-            <a:r>
-              <a:rPr lang="en-US" sz="1300" dirty="0">
+              <a:lnSpc>
+                <a:spcPct val="112000"/>
+              </a:lnSpc>
+              <a:buNone/>
+            </a:pPr>
+            <a:r>
+              <a:rPr lang="en-US" sz="1250" dirty="0">
                 <a:solidFill>
                   <a:srgbClr val="27313F"/>
                 </a:solidFill>
@@ -12281,22 +12690,22 @@
                 <a:ea typeface="Calibri" pitchFamily="34" charset="-122"/>
                 <a:cs typeface="Calibri" pitchFamily="34" charset="-120"/>
               </a:rPr>
-              <a:t>uplift from the lending overlay vs price-trading alone ($23.0M → $27.3M), like-for-like.</a:t>
-            </a:r>
-            <a:endParaRPr lang="en-US" sz="1300" dirty="0"/>
-          </a:p>
-        </p:txBody>
-      </p:sp>
-      <p:sp>
-        <p:nvSpPr>
-          <p:cNvPr id="12" name="Text 9"/>
+              <a:t>Long price is stable (~$15M); lending income runs $0.6M → $4.3M → $17.4M across regimes. It adds +18% over price-only.</a:t>
+            </a:r>
+            <a:endParaRPr lang="en-US" sz="1250" dirty="0"/>
+          </a:p>
+        </p:txBody>
+      </p:sp>
+      <p:sp>
+        <p:nvSpPr>
+          <p:cNvPr id="10" name="Text 7"/>
           <p:cNvSpPr/>
           <p:nvPr/>
         </p:nvSpPr>
         <p:spPr>
           <a:xfrm>
-            <a:off x="548640" y="5257800"/>
-            <a:ext cx="11064240" cy="822960"/>
+            <a:off x="548640" y="5303520"/>
+            <a:ext cx="11064240" cy="731520"/>
           </a:xfrm>
           <a:prstGeom prst="rect">
             <a:avLst/>
@@ -12310,12 +12719,12 @@
           <a:p>
             <a:pPr indent="0" marL="0">
               <a:lnSpc>
-                <a:spcPct val="115000"/>
+                <a:spcPct val="112000"/>
               </a:lnSpc>
               <a:buNone/>
             </a:pPr>
             <a:r>
-              <a:rPr lang="en-US" sz="1400" b="1" dirty="0">
+              <a:rPr lang="en-US" sz="1350" b="1" dirty="0">
                 <a:solidFill>
                   <a:srgbClr val="1E2761"/>
                 </a:solidFill>
@@ -12323,16 +12732,16 @@
                 <a:ea typeface="Calibri" pitchFamily="34" charset="-122"/>
                 <a:cs typeface="Calibri" pitchFamily="34" charset="-120"/>
               </a:rPr>
-              <a:t>The risk is not the short leg — it is misclassifying a failure as a winner.  </a:t>
+              <a:t>The real risk is not the short leg — it is misclassifying a failure as a winner.  </a:t>
             </a:r>
             <a:pPr indent="0" marL="0">
               <a:lnSpc>
-                <a:spcPct val="115000"/>
+                <a:spcPct val="112000"/>
               </a:lnSpc>
               <a:buNone/>
             </a:pPr>
             <a:r>
-              <a:rPr lang="en-US" sz="1400" dirty="0">
+              <a:rPr lang="en-US" sz="1350" dirty="0">
                 <a:solidFill>
                   <a:srgbClr val="5B636E"/>
                 </a:solidFill>
@@ -12340,15 +12749,15 @@
                 <a:ea typeface="Calibri" pitchFamily="34" charset="-122"/>
                 <a:cs typeface="Calibri" pitchFamily="34" charset="-120"/>
               </a:rPr>
-              <a:t>A wrong long buys a landmine that gaps −15%. That is why failure-class precision, not raw accuracy, is the number that matters.</a:t>
-            </a:r>
-            <a:endParaRPr lang="en-US" sz="1400" dirty="0"/>
-          </a:p>
-        </p:txBody>
-      </p:sp>
-      <p:sp>
-        <p:nvSpPr>
-          <p:cNvPr id="13" name="Text 10"/>
+              <a:t>A wrong long buys a landmine that gaps −15%. Failure-class precision, not raw accuracy, is the number that matters.</a:t>
+            </a:r>
+            <a:endParaRPr lang="en-US" sz="1350" dirty="0"/>
+          </a:p>
+        </p:txBody>
+      </p:sp>
+      <p:sp>
+        <p:nvSpPr>
+          <p:cNvPr id="11" name="Text 8"/>
           <p:cNvSpPr/>
           <p:nvPr/>
         </p:nvSpPr>
@@ -12565,11 +12974,11 @@
             <a:tbl>
               <a:tblPr/>
               <a:tblGrid>
-                <a:gridCol w="3291840"/>
-                <a:gridCol w="1554480"/>
-                <a:gridCol w="1554480"/>
+                <a:gridCol w="3383280"/>
+                <a:gridCol w="1508760"/>
+                <a:gridCol w="1508760"/>
               </a:tblGrid>
-              <a:tr h="502920">
+              <a:tr h="475488">
                 <a:tc>
                   <a:txBody>
                     <a:bodyPr/>
@@ -12775,7 +13184,7 @@
                   </a:tcPr>
                 </a:tc>
               </a:tr>
-              <a:tr h="502920">
+              <a:tr h="475488">
                 <a:tc>
                   <a:txBody>
                     <a:bodyPr/>
@@ -12861,7 +13270,7 @@
                           <a:ea typeface="Calibri" pitchFamily="34" charset="-122"/>
                           <a:cs typeface="Calibri" pitchFamily="34" charset="-120"/>
                         </a:rPr>
-                        <a:t>$23.2M · 0% loss</a:t>
+                        <a:t>$26.6M</a:t>
                       </a:r>
                       <a:endParaRPr lang="en-US" sz="1150" dirty="0">
                         <a:latin typeface="Calibri" charset="0"/>
@@ -12929,7 +13338,7 @@
                           <a:ea typeface="Calibri" pitchFamily="34" charset="-122"/>
                           <a:cs typeface="Calibri" pitchFamily="34" charset="-120"/>
                         </a:rPr>
-                        <a:t>$18.7M · 1.5% loss</a:t>
+                        <a:t>$23.8M</a:t>
                       </a:r>
                       <a:endParaRPr lang="en-US" sz="1150" dirty="0">
                         <a:latin typeface="Calibri" charset="0"/>
@@ -12981,7 +13390,7 @@
                   </a:tcPr>
                 </a:tc>
               </a:tr>
-              <a:tr h="502920">
+              <a:tr h="475488">
                 <a:tc>
                   <a:txBody>
                     <a:bodyPr/>
@@ -13067,7 +13476,7 @@
                           <a:ea typeface="Calibri" pitchFamily="34" charset="-122"/>
                           <a:cs typeface="Calibri" pitchFamily="34" charset="-120"/>
                         </a:rPr>
-                        <a:t>$23.6M</a:t>
+                        <a:t>$26.9M</a:t>
                       </a:r>
                       <a:endParaRPr lang="en-US" sz="1150" dirty="0">
                         <a:latin typeface="Calibri" charset="0"/>
@@ -13135,7 +13544,7 @@
                           <a:ea typeface="Calibri" pitchFamily="34" charset="-122"/>
                           <a:cs typeface="Calibri" pitchFamily="34" charset="-120"/>
                         </a:rPr>
-                        <a:t>$18.8M</a:t>
+                        <a:t>$24.5M</a:t>
                       </a:r>
                       <a:endParaRPr lang="en-US" sz="1150" dirty="0">
                         <a:latin typeface="Calibri" charset="0"/>
@@ -13187,7 +13596,7 @@
                   </a:tcPr>
                 </a:tc>
               </a:tr>
-              <a:tr h="502920">
+              <a:tr h="475488">
                 <a:tc>
                   <a:txBody>
                     <a:bodyPr/>
@@ -13205,7 +13614,7 @@
                           <a:ea typeface="Calibri" pitchFamily="34" charset="-122"/>
                           <a:cs typeface="Calibri" pitchFamily="34" charset="-120"/>
                         </a:rPr>
-                        <a:t>B2. Assumptions, correlated (copula)</a:t>
+                        <a:t>B2. Assumptions, correlated — hedged</a:t>
                       </a:r>
                       <a:endParaRPr lang="en-US" sz="1150" dirty="0">
                         <a:latin typeface="Calibri" charset="0"/>
@@ -13273,7 +13682,7 @@
                           <a:ea typeface="Calibri" pitchFamily="34" charset="-122"/>
                           <a:cs typeface="Calibri" pitchFamily="34" charset="-120"/>
                         </a:rPr>
-                        <a:t>$23.7M</a:t>
+                        <a:t>$26.7M</a:t>
                       </a:r>
                       <a:endParaRPr lang="en-US" sz="1150" dirty="0">
                         <a:latin typeface="Calibri" charset="0"/>
@@ -13341,7 +13750,7 @@
                           <a:ea typeface="Calibri" pitchFamily="34" charset="-122"/>
                           <a:cs typeface="Calibri" pitchFamily="34" charset="-120"/>
                         </a:rPr>
-                        <a:t>$18.9M</a:t>
+                        <a:t>$24.2M</a:t>
                       </a:r>
                       <a:endParaRPr lang="en-US" sz="1150" dirty="0">
                         <a:latin typeface="Calibri" charset="0"/>
@@ -13393,7 +13802,213 @@
                   </a:tcPr>
                 </a:tc>
               </a:tr>
-              <a:tr h="502920">
+              <a:tr h="475488">
+                <a:tc>
+                  <a:txBody>
+                    <a:bodyPr/>
+                    <a:lstStyle/>
+                    <a:p>
+                      <a:pPr algn="l" indent="0" marL="0">
+                        <a:buNone/>
+                      </a:pPr>
+                      <a:r>
+                        <a:rPr lang="en-US" sz="1150" dirty="0">
+                          <a:solidFill>
+                            <a:srgbClr val="27313F"/>
+                          </a:solidFill>
+                          <a:latin typeface="Calibri" pitchFamily="34" charset="0"/>
+                          <a:ea typeface="Calibri" pitchFamily="34" charset="-122"/>
+                          <a:cs typeface="Calibri" pitchFamily="34" charset="-120"/>
+                        </a:rPr>
+                        <a:t>B2 correlated — un-hedged</a:t>
+                      </a:r>
+                      <a:endParaRPr lang="en-US" sz="1150" dirty="0">
+                        <a:latin typeface="Calibri" charset="0"/>
+                        <a:ea typeface="Calibri" charset="0"/>
+                        <a:cs typeface="Calibri" charset="0"/>
+                      </a:endParaRPr>
+                    </a:p>
+                  </a:txBody>
+                  <a:tcPr marL="91440" marR="91440" marT="45720" marB="45720" anchor="ctr">
+                    <a:lnL w="12700" cap="flat" cmpd="sng" algn="ctr">
+                      <a:solidFill>
+                        <a:srgbClr val="E4E6EE"/>
+                      </a:solidFill>
+                      <a:prstDash val="solid"/>
+                      <a:round/>
+                      <a:headEnd type="none" w="med" len="med"/>
+                      <a:tailEnd type="none" w="med" len="med"/>
+                    </a:lnL>
+                    <a:lnR w="12700" cap="flat" cmpd="sng" algn="ctr">
+                      <a:solidFill>
+                        <a:srgbClr val="E4E6EE"/>
+                      </a:solidFill>
+                      <a:prstDash val="solid"/>
+                      <a:round/>
+                      <a:headEnd type="none" w="med" len="med"/>
+                      <a:tailEnd type="none" w="med" len="med"/>
+                    </a:lnR>
+                    <a:lnT w="12700" cap="flat" cmpd="sng" algn="ctr">
+                      <a:solidFill>
+                        <a:srgbClr val="E4E6EE"/>
+                      </a:solidFill>
+                      <a:prstDash val="solid"/>
+                      <a:round/>
+                      <a:headEnd type="none" w="med" len="med"/>
+                      <a:tailEnd type="none" w="med" len="med"/>
+                    </a:lnT>
+                    <a:lnB w="12700" cap="flat" cmpd="sng" algn="ctr">
+                      <a:solidFill>
+                        <a:srgbClr val="E4E6EE"/>
+                      </a:solidFill>
+                      <a:prstDash val="solid"/>
+                      <a:round/>
+                      <a:headEnd type="none" w="med" len="med"/>
+                      <a:tailEnd type="none" w="med" len="med"/>
+                    </a:lnB>
+                    <a:solidFill>
+                      <a:srgbClr val="FFFFFF"/>
+                    </a:solidFill>
+                  </a:tcPr>
+                </a:tc>
+                <a:tc>
+                  <a:txBody>
+                    <a:bodyPr/>
+                    <a:lstStyle/>
+                    <a:p>
+                      <a:pPr algn="ctr" indent="0" marL="0">
+                        <a:buNone/>
+                      </a:pPr>
+                      <a:r>
+                        <a:rPr lang="en-US" sz="1150" dirty="0">
+                          <a:solidFill>
+                            <a:srgbClr val="27313F"/>
+                          </a:solidFill>
+                          <a:latin typeface="Calibri" pitchFamily="34" charset="0"/>
+                          <a:ea typeface="Calibri" pitchFamily="34" charset="-122"/>
+                          <a:cs typeface="Calibri" pitchFamily="34" charset="-120"/>
+                        </a:rPr>
+                        <a:t>$30.4M</a:t>
+                      </a:r>
+                      <a:endParaRPr lang="en-US" sz="1150" dirty="0">
+                        <a:latin typeface="Calibri" charset="0"/>
+                        <a:ea typeface="Calibri" charset="0"/>
+                        <a:cs typeface="Calibri" charset="0"/>
+                      </a:endParaRPr>
+                    </a:p>
+                  </a:txBody>
+                  <a:tcPr marL="91440" marR="91440" marT="45720" marB="45720" anchor="ctr">
+                    <a:lnL w="12700" cap="flat" cmpd="sng" algn="ctr">
+                      <a:solidFill>
+                        <a:srgbClr val="E4E6EE"/>
+                      </a:solidFill>
+                      <a:prstDash val="solid"/>
+                      <a:round/>
+                      <a:headEnd type="none" w="med" len="med"/>
+                      <a:tailEnd type="none" w="med" len="med"/>
+                    </a:lnL>
+                    <a:lnR w="12700" cap="flat" cmpd="sng" algn="ctr">
+                      <a:solidFill>
+                        <a:srgbClr val="E4E6EE"/>
+                      </a:solidFill>
+                      <a:prstDash val="solid"/>
+                      <a:round/>
+                      <a:headEnd type="none" w="med" len="med"/>
+                      <a:tailEnd type="none" w="med" len="med"/>
+                    </a:lnR>
+                    <a:lnT w="12700" cap="flat" cmpd="sng" algn="ctr">
+                      <a:solidFill>
+                        <a:srgbClr val="E4E6EE"/>
+                      </a:solidFill>
+                      <a:prstDash val="solid"/>
+                      <a:round/>
+                      <a:headEnd type="none" w="med" len="med"/>
+                      <a:tailEnd type="none" w="med" len="med"/>
+                    </a:lnT>
+                    <a:lnB w="12700" cap="flat" cmpd="sng" algn="ctr">
+                      <a:solidFill>
+                        <a:srgbClr val="E4E6EE"/>
+                      </a:solidFill>
+                      <a:prstDash val="solid"/>
+                      <a:round/>
+                      <a:headEnd type="none" w="med" len="med"/>
+                      <a:tailEnd type="none" w="med" len="med"/>
+                    </a:lnB>
+                    <a:solidFill>
+                      <a:srgbClr val="FFFFFF"/>
+                    </a:solidFill>
+                  </a:tcPr>
+                </a:tc>
+                <a:tc>
+                  <a:txBody>
+                    <a:bodyPr/>
+                    <a:lstStyle/>
+                    <a:p>
+                      <a:pPr algn="ctr" indent="0" marL="0">
+                        <a:buNone/>
+                      </a:pPr>
+                      <a:r>
+                        <a:rPr lang="en-US" sz="1150" dirty="0">
+                          <a:solidFill>
+                            <a:srgbClr val="27313F"/>
+                          </a:solidFill>
+                          <a:latin typeface="Calibri" pitchFamily="34" charset="0"/>
+                          <a:ea typeface="Calibri" pitchFamily="34" charset="-122"/>
+                          <a:cs typeface="Calibri" pitchFamily="34" charset="-120"/>
+                        </a:rPr>
+                        <a:t>$27.6M</a:t>
+                      </a:r>
+                      <a:endParaRPr lang="en-US" sz="1150" dirty="0">
+                        <a:latin typeface="Calibri" charset="0"/>
+                        <a:ea typeface="Calibri" charset="0"/>
+                        <a:cs typeface="Calibri" charset="0"/>
+                      </a:endParaRPr>
+                    </a:p>
+                  </a:txBody>
+                  <a:tcPr marL="91440" marR="91440" marT="45720" marB="45720" anchor="ctr">
+                    <a:lnL w="12700" cap="flat" cmpd="sng" algn="ctr">
+                      <a:solidFill>
+                        <a:srgbClr val="E4E6EE"/>
+                      </a:solidFill>
+                      <a:prstDash val="solid"/>
+                      <a:round/>
+                      <a:headEnd type="none" w="med" len="med"/>
+                      <a:tailEnd type="none" w="med" len="med"/>
+                    </a:lnL>
+                    <a:lnR w="12700" cap="flat" cmpd="sng" algn="ctr">
+                      <a:solidFill>
+                        <a:srgbClr val="E4E6EE"/>
+                      </a:solidFill>
+                      <a:prstDash val="solid"/>
+                      <a:round/>
+                      <a:headEnd type="none" w="med" len="med"/>
+                      <a:tailEnd type="none" w="med" len="med"/>
+                    </a:lnR>
+                    <a:lnT w="12700" cap="flat" cmpd="sng" algn="ctr">
+                      <a:solidFill>
+                        <a:srgbClr val="E4E6EE"/>
+                      </a:solidFill>
+                      <a:prstDash val="solid"/>
+                      <a:round/>
+                      <a:headEnd type="none" w="med" len="med"/>
+                      <a:tailEnd type="none" w="med" len="med"/>
+                    </a:lnT>
+                    <a:lnB w="12700" cap="flat" cmpd="sng" algn="ctr">
+                      <a:solidFill>
+                        <a:srgbClr val="E4E6EE"/>
+                      </a:solidFill>
+                      <a:prstDash val="solid"/>
+                      <a:round/>
+                      <a:headEnd type="none" w="med" len="med"/>
+                      <a:tailEnd type="none" w="med" len="med"/>
+                    </a:lnB>
+                    <a:solidFill>
+                      <a:srgbClr val="FFFFFF"/>
+                    </a:solidFill>
+                  </a:tcPr>
+                </a:tc>
+              </a:tr>
+              <a:tr h="475488">
                 <a:tc>
                   <a:txBody>
                     <a:bodyPr/>
@@ -13411,7 +14026,7 @@
                           <a:ea typeface="Calibri" pitchFamily="34" charset="-122"/>
                           <a:cs typeface="Calibri" pitchFamily="34" charset="-120"/>
                         </a:rPr>
-                        <a:t>Full-risk (accuracy also random)</a:t>
+                        <a:t>P(lose money over 4yr)</a:t>
                       </a:r>
                       <a:endParaRPr lang="en-US" sz="1150" dirty="0">
                         <a:latin typeface="Calibri" charset="0"/>
@@ -13471,15 +14086,15 @@
                         <a:buNone/>
                       </a:pPr>
                       <a:r>
-                        <a:rPr lang="en-US" sz="1150" i="1" dirty="0">
+                        <a:rPr lang="en-US" sz="1150" b="1" dirty="0">
                           <a:solidFill>
-                            <a:srgbClr val="5B636E"/>
+                            <a:srgbClr val="02C39A"/>
                           </a:solidFill>
                           <a:latin typeface="Calibri" pitchFamily="34" charset="0"/>
                           <a:ea typeface="Calibri" pitchFamily="34" charset="-122"/>
                           <a:cs typeface="Calibri" pitchFamily="34" charset="-120"/>
                         </a:rPr>
-                        <a:t>median $21.4M · [11.3, 29.4] · 3.7% loss</a:t>
+                        <a:t>0% in every cell</a:t>
                       </a:r>
                       <a:endParaRPr lang="en-US" sz="1150" dirty="0">
                         <a:latin typeface="Calibri" charset="0"/>
@@ -13546,8 +14161,8 @@
         </p:nvSpPr>
         <p:spPr>
           <a:xfrm>
-            <a:off x="548640" y="4160520"/>
-            <a:ext cx="6400800" cy="1828800"/>
+            <a:off x="548640" y="4617720"/>
+            <a:ext cx="6400800" cy="1554480"/>
           </a:xfrm>
           <a:prstGeom prst="rect">
             <a:avLst/>
@@ -13561,12 +14176,12 @@
           <a:p>
             <a:pPr indent="0" marL="0">
               <a:lnSpc>
-                <a:spcPct val="122000"/>
+                <a:spcPct val="120000"/>
               </a:lnSpc>
               <a:buNone/>
             </a:pPr>
             <a:r>
-              <a:rPr lang="en-US" sz="1350" b="1" dirty="0">
+              <a:rPr lang="en-US" sz="1300" b="1" dirty="0">
                 <a:solidFill>
                   <a:srgbClr val="1E2761"/>
                 </a:solidFill>
@@ -13578,12 +14193,12 @@
             </a:r>
             <a:pPr indent="0" marL="0">
               <a:lnSpc>
-                <a:spcPct val="122000"/>
+                <a:spcPct val="120000"/>
               </a:lnSpc>
               <a:buNone/>
             </a:pPr>
             <a:r>
-              <a:rPr lang="en-US" sz="1350" dirty="0">
+              <a:rPr lang="en-US" sz="1300" dirty="0">
                 <a:solidFill>
                   <a:srgbClr val="27313F"/>
                 </a:solidFill>
@@ -13591,16 +14206,16 @@
                 <a:ea typeface="Calibri" pitchFamily="34" charset="-122"/>
                 <a:cs typeface="Calibri" pitchFamily="34" charset="-120"/>
               </a:rPr>
-              <a:t>— the result is neither a few lucky deals nor lucky cost guesses. Correlating the assumptions (a stress regime) trims the upside only mildly. </a:t>
+              <a:t>— not a few lucky deals nor lucky cost guesses. Dropping the short leg removed the downside: </a:t>
             </a:r>
             <a:pPr indent="0" marL="0">
               <a:lnSpc>
-                <a:spcPct val="122000"/>
+                <a:spcPct val="120000"/>
               </a:lnSpc>
               <a:buNone/>
             </a:pPr>
             <a:r>
-              <a:rPr lang="en-US" sz="1350" b="1" dirty="0">
+              <a:rPr lang="en-US" sz="1300" b="1" dirty="0">
                 <a:solidFill>
                   <a:srgbClr val="02C39A"/>
                 </a:solidFill>
@@ -13608,9 +14223,26 @@
                 <a:ea typeface="Calibri" pitchFamily="34" charset="-122"/>
                 <a:cs typeface="Calibri" pitchFamily="34" charset="-120"/>
               </a:rPr>
-              <a:t>The one lever that dominates is model accuracy.</a:t>
-            </a:r>
-            <a:endParaRPr lang="en-US" sz="1350" dirty="0"/>
+              <a:t>P(loss) is 0% everywhere. </a:t>
+            </a:r>
+            <a:pPr indent="0" marL="0">
+              <a:lnSpc>
+                <a:spcPct val="120000"/>
+              </a:lnSpc>
+              <a:buNone/>
+            </a:pPr>
+            <a:r>
+              <a:rPr lang="en-US" sz="1300" dirty="0">
+                <a:solidFill>
+                  <a:srgbClr val="27313F"/>
+                </a:solidFill>
+                <a:latin typeface="Calibri" pitchFamily="34" charset="0"/>
+                <a:ea typeface="Calibri" pitchFamily="34" charset="-122"/>
+                <a:cs typeface="Calibri" pitchFamily="34" charset="-120"/>
+              </a:rPr>
+              <a:t>Un-hedged sits ~$3–4M higher (the hedge cost return here). The lever that dominates is model accuracy.</a:t>
+            </a:r>
+            <a:endParaRPr lang="en-US" sz="1300" dirty="0"/>
           </a:p>
         </p:txBody>
       </p:sp>
@@ -13663,7 +14295,7 @@
               <a:buNone/>
             </a:pPr>
             <a:r>
-              <a:rPr lang="en-US" sz="1050" i="1" dirty="0">
+              <a:rPr lang="en-US" sz="1000" i="1" dirty="0">
                 <a:solidFill>
                   <a:srgbClr val="8A919B"/>
                 </a:solidFill>
@@ -13671,9 +14303,9 @@
                 <a:ea typeface="Calibri" pitchFamily="34" charset="-122"/>
                 <a:cs typeface="Calibri" pitchFamily="34" charset="-120"/>
               </a:rPr>
-              <a:t>Bootstrap vs assumption MC at 90% (top) and 80% (bottom). Orange = correlated.</a:t>
-            </a:r>
-            <a:endParaRPr lang="en-US" sz="1050" dirty="0"/>
+              <a:t>Density-normalized so all curves compare despite different sample counts. 90% (top) / 80% (bottom); purple = un-hedged.</a:t>
+            </a:r>
+            <a:endParaRPr lang="en-US" sz="1000" dirty="0"/>
           </a:p>
         </p:txBody>
       </p:sp>

</xml_diff>

<commit_message>
Critical-review fixes: remove stale tornado, complete @90% row, regime caveat, readable legends, sample sizes
- Remove the stale sensitivity tornado from the IC brief (it swept the
  with-short universe; redundant with the long+lend OAT-MC)
- Complete the fair-comparison row: strategy @90% model = $26.3M / Sharpe 1.47 / -18%
- Add the regime caveat: P(loss)=0% is conditional on a 2016-2019-like market
  (all MC price paths are from that window); sharpen the hedge = tail-insurance rationale
- Enlarge equity + MC chart legends; add readable HTML line-legends under both charts
- Add prominent sample sizes (320 = 217 successes + 103 failures) to the IC brief
- Deck: same @90% row + regime caveat; sample sizes already on slides 2 & 8
</commit_message>
<xml_diff>
--- a/reports/IC_Biotech_Catalyst_Strategy.pptx
+++ b/reports/IC_Biotech_Catalyst_Strategy.pptx
@@ -3996,7 +3996,7 @@
                 <a:ea typeface="Calibri" pitchFamily="34" charset="-122"/>
                 <a:cs typeface="Calibri" pitchFamily="34" charset="-120"/>
               </a:rPr>
-              <a:t>Both are swept in the one-at-a-time and joint Monte Carlo; neither breaks the strategy (P(loss)=0%), but the borrow rate is un-measured until we trade, and accuracy is what Step 3/4 must deliver. Window capped pre-COVID; short executability is gone (leg dropped).</a:t>
+              <a:t>Both are swept in the one-at-a-time and joint Monte Carlo; neither breaks the strategy, but the borrow rate is un-measured until we trade, and accuracy is what Step 3/4 must deliver. Note P(loss)=0% is conditional — every MC path is from 2016-2019, so it does NOT test a different market regime (that's what the hedge is for).</a:t>
             </a:r>
             <a:endParaRPr lang="en-US" sz="1250" dirty="0"/>
           </a:p>
@@ -9610,7 +9610,7 @@
                           <a:ea typeface="Calibri" pitchFamily="34" charset="-122"/>
                           <a:cs typeface="Calibri" pitchFamily="34" charset="-120"/>
                         </a:rPr>
-                        <a:t>$26.1M</a:t>
+                        <a:t>$26.3M</a:t>
                       </a:r>
                       <a:endParaRPr lang="en-US" sz="1200" dirty="0">
                         <a:latin typeface="Calibri" charset="0"/>
@@ -9746,7 +9746,7 @@
                           <a:ea typeface="Calibri" pitchFamily="34" charset="-122"/>
                           <a:cs typeface="Calibri" pitchFamily="34" charset="-120"/>
                         </a:rPr>
-                        <a:t>—</a:t>
+                        <a:t>1.47</a:t>
                       </a:r>
                       <a:endParaRPr lang="en-US" sz="1200" dirty="0">
                         <a:latin typeface="Calibri" charset="0"/>
@@ -9814,7 +9814,7 @@
                           <a:ea typeface="Calibri" pitchFamily="34" charset="-122"/>
                           <a:cs typeface="Calibri" pitchFamily="34" charset="-120"/>
                         </a:rPr>
-                        <a:t>—</a:t>
+                        <a:t>−18%</a:t>
                       </a:r>
                       <a:endParaRPr lang="en-US" sz="1200" dirty="0">
                         <a:latin typeface="Calibri" charset="0"/>

</xml_diff>

<commit_message>
Swap hero to realistic 90% model ($26.3M); re-baseline detailed report to long+lend
- IC brief + deck hero: headline is now the realistic 90%-model result
  ($26.3M / 27% / 1.47 / -18%), perfect-foresight $28.9M shown as the ceiling
- Detailed report fully re-baselined to the deployed long+lend book:
  per-scenario leg-split (drop-short proof), benchmark vs S&P/XBI + 90% row,
  hedged-vs-unhedged, OAT at 90/80 (borrow rate dominates), long+lend MC with
  P(loss)=0% + regime caveat, corrected P&L, sample sizes (320=217+103);
  stale sensitivity tornado removed
</commit_message>
<xml_diff>
--- a/reports/IC_Biotech_Catalyst_Strategy.pptx
+++ b/reports/IC_Biotech_Catalyst_Strategy.pptx
@@ -8493,7 +8493,7 @@
                 <a:ea typeface="Calibri" pitchFamily="34" charset="-122"/>
                 <a:cs typeface="Calibri" pitchFamily="34" charset="-120"/>
               </a:rPr>
-              <a:t>2016–2019, small-cap, capped pre-COVID · perfect-foresight; realistic 90% model ~$26M</a:t>
+              <a:t>2016–2019, small-cap, capped pre-COVID · headline = realistic 90% model; perfect-foresight ceiling $28.9M</a:t>
             </a:r>
             <a:endParaRPr lang="en-US" sz="1250" dirty="0"/>
           </a:p>
@@ -8532,7 +8532,7 @@
                 <a:ea typeface="Cambria" pitchFamily="34" charset="-122"/>
                 <a:cs typeface="Cambria" pitchFamily="34" charset="-120"/>
               </a:rPr>
-              <a:t>$28.9M</a:t>
+              <a:t>$26.3M</a:t>
             </a:r>
             <a:endParaRPr lang="en-US" sz="3400" dirty="0"/>
           </a:p>
@@ -8571,7 +8571,7 @@
                 <a:ea typeface="Calibri" pitchFamily="34" charset="-122"/>
                 <a:cs typeface="Calibri" pitchFamily="34" charset="-120"/>
               </a:rPr>
-              <a:t>$10M grows to</a:t>
+              <a:t>$10M grows to (90% model)</a:t>
             </a:r>
             <a:endParaRPr lang="en-US" sz="1150" dirty="0"/>
           </a:p>
@@ -8610,7 +8610,7 @@
                 <a:ea typeface="Cambria" pitchFamily="34" charset="-122"/>
                 <a:cs typeface="Cambria" pitchFamily="34" charset="-120"/>
               </a:rPr>
-              <a:t>29%</a:t>
+              <a:t>27%</a:t>
             </a:r>
             <a:endParaRPr lang="en-US" sz="3400" dirty="0"/>
           </a:p>
@@ -8688,7 +8688,7 @@
                 <a:ea typeface="Cambria" pitchFamily="34" charset="-122"/>
                 <a:cs typeface="Cambria" pitchFamily="34" charset="-120"/>
               </a:rPr>
-              <a:t>1.65</a:t>
+              <a:t>1.47</a:t>
             </a:r>
             <a:endParaRPr lang="en-US" sz="3400" dirty="0"/>
           </a:p>
@@ -8766,7 +8766,7 @@
                 <a:ea typeface="Cambria" pitchFamily="34" charset="-122"/>
                 <a:cs typeface="Cambria" pitchFamily="34" charset="-120"/>
               </a:rPr>
-              <a:t>−16%</a:t>
+              <a:t>−18%</a:t>
             </a:r>
             <a:endParaRPr lang="en-US" sz="3400" dirty="0"/>
           </a:p>

</xml_diff>